<commit_message>
Add KuaiRand-1k bonus benchmark deliverables
- final 1k submission (submission_1k.csv.gz, test primary 0.7805, +0.1415 vs baseline)
- 1k pipeline (final_submission_1k.py, row-order fixed)
- 1k results summary (RESULTS_SUMMARY_1k.md)
- 1k task description (instructions_1k.txt)
- README: bonus section + layout update
</commit_message>
<xml_diff>
--- a/Autonomous-ML-Agent-KuaiRand.pptx
+++ b/Autonomous-ML-Agent-KuaiRand.pptx
@@ -1,25 +1,25 @@
 
 <file path=ppt/presentation.xml><?xml version="1.0" encoding="utf-8"?>
-<p:presentation xmlns:a="http://schemas.openxmlformats.org/drawingml/2006/main" xmlns:r="http://schemas.openxmlformats.org/officeDocument/2006/relationships" xmlns:p="http://schemas.openxmlformats.org/presentationml/2006/main" saveSubsetFonts="1" autoCompressPictures="0">
+<p:presentation xmlns:a="http://schemas.openxmlformats.org/drawingml/2006/main" xmlns:r="http://schemas.openxmlformats.org/officeDocument/2006/relationships" xmlns:p="http://schemas.openxmlformats.org/presentationml/2006/main" firstSlideNum="1">
   <p:sldMasterIdLst>
-    <p:sldMasterId id="2147483648" r:id="rId1"/>
+    <p:sldMasterId id="2147483648" r:id="rId0"/>
   </p:sldMasterIdLst>
+  <p:notesMasterIdLst>
+    <p:notesMasterId r:id="rId12"/>
+  </p:notesMasterIdLst>
   <p:sldIdLst>
-    <p:sldId id="256" r:id="rId2"/>
-    <p:sldId id="257" r:id="rId3"/>
-    <p:sldId id="258" r:id="rId4"/>
-    <p:sldId id="259" r:id="rId5"/>
-    <p:sldId id="260" r:id="rId6"/>
-    <p:sldId id="261" r:id="rId7"/>
-    <p:sldId id="262" r:id="rId8"/>
-    <p:sldId id="263" r:id="rId9"/>
-    <p:sldId id="264" r:id="rId10"/>
-    <p:sldId id="265" r:id="rId11"/>
-    <p:sldId id="266" r:id="rId12"/>
+    <p:sldId id="256" r:id="rId1"/>
+    <p:sldId id="257" r:id="rId2"/>
+    <p:sldId id="258" r:id="rId3"/>
+    <p:sldId id="259" r:id="rId4"/>
+    <p:sldId id="260" r:id="rId5"/>
+    <p:sldId id="261" r:id="rId6"/>
+    <p:sldId id="262" r:id="rId7"/>
+    <p:sldId id="263" r:id="rId8"/>
+    <p:sldId id="264" r:id="rId9"/>
+    <p:sldId id="265" r:id="rId10"/>
+    <p:sldId id="266" r:id="rId11"/>
   </p:sldIdLst>
-  <p:notesMasterIdLst>
-    <p:notesMasterId r:id="rId13"/>
-  </p:notesMasterIdLst>
   <p:sldSz cx="9144000" cy="5143500"/>
   <p:notesSz cx="5143500" cy="9144000"/>
   <p:defaultTextStyle>
@@ -118,7 +118,7 @@
 </file>
 
 <file path=ppt/notesMasters/notesMaster1.xml><?xml version="1.0" encoding="utf-8"?>
-<p:notesMaster xmlns:a="http://schemas.openxmlformats.org/drawingml/2006/main" xmlns:r="http://schemas.openxmlformats.org/officeDocument/2006/relationships" xmlns:p="http://schemas.openxmlformats.org/presentationml/2006/main">
+<p:notesMaster xmlns:a="http://schemas.openxmlformats.org/drawingml/2006/main" xmlns:p="http://schemas.openxmlformats.org/presentationml/2006/main">
   <p:cSld>
     <p:bg>
       <p:bgRef idx="1001">
@@ -166,6 +166,7 @@
             </a:lvl1pPr>
           </a:lstStyle>
           <a:p>
+            <a:pPr/>
             <a:endParaRPr lang="en-US"/>
           </a:p>
         </p:txBody>
@@ -197,6 +198,7 @@
             </a:lvl1pPr>
           </a:lstStyle>
           <a:p>
+            <a:pPr/>
             <a:fld id="{5282F153-3F37-0F45-9E97-73ACFA13230C}" type="datetimeFigureOut">
               <a:rPr lang="en-US"/>
               <a:t>7/23/19</a:t>
@@ -234,6 +236,7 @@
           <a:bodyPr vert="horz" lIns="91440" tIns="45720" rIns="91440" bIns="45720" rtlCol="0" anchor="ctr"/>
           <a:lstStyle/>
           <a:p>
+            <a:pPr/>
             <a:endParaRPr lang="en-US"/>
           </a:p>
         </p:txBody>
@@ -266,6 +269,7 @@
               <a:rPr lang="en-US"/>
               <a:t>Click to edit Master text styles</a:t>
             </a:r>
+            <a:endParaRPr/>
           </a:p>
           <a:p>
             <a:pPr lvl="1"/>
@@ -273,6 +277,7 @@
               <a:rPr lang="en-US"/>
               <a:t>Second level</a:t>
             </a:r>
+            <a:endParaRPr/>
           </a:p>
           <a:p>
             <a:pPr lvl="2"/>
@@ -280,6 +285,7 @@
               <a:rPr lang="en-US"/>
               <a:t>Third level</a:t>
             </a:r>
+            <a:endParaRPr/>
           </a:p>
           <a:p>
             <a:pPr lvl="3"/>
@@ -287,6 +293,7 @@
               <a:rPr lang="en-US"/>
               <a:t>Fourth level</a:t>
             </a:r>
+            <a:endParaRPr/>
           </a:p>
           <a:p>
             <a:pPr lvl="4"/>
@@ -294,6 +301,7 @@
               <a:rPr lang="en-US"/>
               <a:t>Fifth level</a:t>
             </a:r>
+            <a:endParaRPr/>
           </a:p>
         </p:txBody>
       </p:sp>
@@ -324,6 +332,7 @@
             </a:lvl1pPr>
           </a:lstStyle>
           <a:p>
+            <a:pPr/>
             <a:endParaRPr lang="en-US"/>
           </a:p>
         </p:txBody>
@@ -355,6 +364,7 @@
             </a:lvl1pPr>
           </a:lstStyle>
           <a:p>
+            <a:pPr/>
             <a:fld id="{CE5E9CC1-C706-0F49-92D6-E571CC5EEA8F}" type="slidenum">
               <a:rPr lang="en-US"/>
               <a:t>‹#›</a:t>
@@ -364,11 +374,6 @@
         </p:txBody>
       </p:sp>
     </p:spTree>
-    <p:extLst>
-      <p:ext uri="{BB962C8B-B14F-4D97-AF65-F5344CB8AC3E}">
-        <p14:creationId xmlns:p14="http://schemas.microsoft.com/office/powerpoint/2010/main" val="1024086991"/>
-      </p:ext>
-    </p:extLst>
   </p:cSld>
   <p:clrMap bg1="lt1" tx1="dk1" bg2="lt2" tx2="dk2" accent1="accent1" accent2="accent2" accent3="accent3" accent4="accent4" accent5="accent5" accent6="accent6" hlink="hlink" folHlink="folHlink"/>
   <p:notesStyle>
@@ -467,7 +472,7 @@
 </file>
 
 <file path=ppt/notesSlides/notesSlide1.xml><?xml version="1.0" encoding="utf-8"?>
-<p:notes xmlns:a="http://schemas.openxmlformats.org/drawingml/2006/main" xmlns:r="http://schemas.openxmlformats.org/officeDocument/2006/relationships" xmlns:p="http://schemas.openxmlformats.org/presentationml/2006/main">
+<p:notes xmlns:a="http://schemas.openxmlformats.org/drawingml/2006/main" xmlns:p="http://schemas.openxmlformats.org/presentationml/2006/main">
   <p:cSld>
     <p:spTree>
       <p:nvGrpSpPr>
@@ -494,6 +499,10 @@
           </p:nvPr>
         </p:nvSpPr>
         <p:spPr/>
+        <p:txBody>
+          <a:bodyPr/>
+          <a:p/>
+        </p:txBody>
       </p:sp>
       <p:sp>
         <p:nvSpPr>
@@ -510,10 +519,7 @@
           <a:bodyPr/>
           <a:lstStyle/>
           <a:p>
-            <a:r>
-              <a:rPr lang="en-US" dirty="0"/>
-              <a:t/>
-            </a:r>
+            <a:pPr/>
             <a:endParaRPr lang="en-US" dirty="0"/>
           </a:p>
         </p:txBody>
@@ -533,6 +539,7 @@
           <a:bodyPr/>
           <a:lstStyle/>
           <a:p>
+            <a:pPr/>
             <a:fld id="{F7021451-1387-4CA6-816F-3879F97B5CBC}" type="slidenum">
               <a:rPr lang="en-US"/>
               <a:t>1</a:t>
@@ -542,11 +549,6 @@
         </p:txBody>
       </p:sp>
     </p:spTree>
-    <p:extLst>
-      <p:ext uri="{BB962C8B-B14F-4D97-AF65-F5344CB8AC3E}">
-        <p14:creationId xmlns:p14="http://schemas.microsoft.com/office/powerpoint/2010/main" val="1024086991"/>
-      </p:ext>
-    </p:extLst>
   </p:cSld>
   <p:clrMapOvr>
     <a:masterClrMapping/>
@@ -555,11 +557,11 @@
 </file>
 
 <file path=ppt/notesSlides/notesSlide10.xml><?xml version="1.0" encoding="utf-8"?>
-<p:notes xmlns:a="http://schemas.openxmlformats.org/drawingml/2006/main" xmlns:r="http://schemas.openxmlformats.org/officeDocument/2006/relationships" xmlns:p="http://schemas.openxmlformats.org/presentationml/2006/main">
+<p:notes xmlns:a="http://schemas.openxmlformats.org/drawingml/2006/main" xmlns:p="http://schemas.openxmlformats.org/presentationml/2006/main">
   <p:cSld>
     <p:spTree>
       <p:nvGrpSpPr>
-        <p:cNvPr id="1" name=""/>
+        <p:cNvPr id="37" name=""/>
         <p:cNvGrpSpPr/>
         <p:nvPr/>
       </p:nvGrpSpPr>
@@ -573,7 +575,7 @@
       </p:grpSpPr>
       <p:sp>
         <p:nvSpPr>
-          <p:cNvPr id="2" name="Slide Image Placeholder 1"/>
+          <p:cNvPr id="38" name="Slide Image Placeholder 1"/>
           <p:cNvSpPr>
             <a:spLocks noGrp="1" noRot="1" noChangeAspect="1"/>
           </p:cNvSpPr>
@@ -582,10 +584,14 @@
           </p:nvPr>
         </p:nvSpPr>
         <p:spPr/>
-      </p:sp>
-      <p:sp>
-        <p:nvSpPr>
-          <p:cNvPr id="3" name="Notes Placeholder 2"/>
+        <p:txBody>
+          <a:bodyPr/>
+          <a:p/>
+        </p:txBody>
+      </p:sp>
+      <p:sp>
+        <p:nvSpPr>
+          <p:cNvPr id="39" name="Notes Placeholder 2"/>
           <p:cNvSpPr>
             <a:spLocks noGrp="1"/>
           </p:cNvSpPr>
@@ -598,17 +604,14 @@
           <a:bodyPr/>
           <a:lstStyle/>
           <a:p>
-            <a:r>
-              <a:rPr lang="en-US" dirty="0"/>
-              <a:t/>
-            </a:r>
+            <a:pPr/>
             <a:endParaRPr lang="en-US" dirty="0"/>
           </a:p>
         </p:txBody>
       </p:sp>
       <p:sp>
         <p:nvSpPr>
-          <p:cNvPr id="4" name="Slide Number Placeholder 3"/>
+          <p:cNvPr id="40" name="Slide Number Placeholder 3"/>
           <p:cNvSpPr>
             <a:spLocks noGrp="1"/>
           </p:cNvSpPr>
@@ -621,20 +624,16 @@
           <a:bodyPr/>
           <a:lstStyle/>
           <a:p>
+            <a:pPr/>
             <a:fld id="{F7021451-1387-4CA6-816F-3879F97B5CBC}" type="slidenum">
               <a:rPr lang="en-US"/>
-              <a:t>10</a:t>
+              <a:t>8</a:t>
             </a:fld>
             <a:endParaRPr lang="en-US"/>
           </a:p>
         </p:txBody>
       </p:sp>
     </p:spTree>
-    <p:extLst>
-      <p:ext uri="{BB962C8B-B14F-4D97-AF65-F5344CB8AC3E}">
-        <p14:creationId xmlns:p14="http://schemas.microsoft.com/office/powerpoint/2010/main" val="1024086991"/>
-      </p:ext>
-    </p:extLst>
   </p:cSld>
   <p:clrMapOvr>
     <a:masterClrMapping/>
@@ -643,11 +642,11 @@
 </file>
 
 <file path=ppt/notesSlides/notesSlide11.xml><?xml version="1.0" encoding="utf-8"?>
-<p:notes xmlns:a="http://schemas.openxmlformats.org/drawingml/2006/main" xmlns:r="http://schemas.openxmlformats.org/officeDocument/2006/relationships" xmlns:p="http://schemas.openxmlformats.org/presentationml/2006/main">
+<p:notes xmlns:a="http://schemas.openxmlformats.org/drawingml/2006/main" xmlns:p="http://schemas.openxmlformats.org/presentationml/2006/main">
   <p:cSld>
     <p:spTree>
       <p:nvGrpSpPr>
-        <p:cNvPr id="1" name=""/>
+        <p:cNvPr id="41" name=""/>
         <p:cNvGrpSpPr/>
         <p:nvPr/>
       </p:nvGrpSpPr>
@@ -661,7 +660,7 @@
       </p:grpSpPr>
       <p:sp>
         <p:nvSpPr>
-          <p:cNvPr id="2" name="Slide Image Placeholder 1"/>
+          <p:cNvPr id="42" name="Slide Image Placeholder 1"/>
           <p:cNvSpPr>
             <a:spLocks noGrp="1" noRot="1" noChangeAspect="1"/>
           </p:cNvSpPr>
@@ -670,10 +669,14 @@
           </p:nvPr>
         </p:nvSpPr>
         <p:spPr/>
-      </p:sp>
-      <p:sp>
-        <p:nvSpPr>
-          <p:cNvPr id="3" name="Notes Placeholder 2"/>
+        <p:txBody>
+          <a:bodyPr/>
+          <a:p/>
+        </p:txBody>
+      </p:sp>
+      <p:sp>
+        <p:nvSpPr>
+          <p:cNvPr id="43" name="Notes Placeholder 2"/>
           <p:cNvSpPr>
             <a:spLocks noGrp="1"/>
           </p:cNvSpPr>
@@ -686,17 +689,14 @@
           <a:bodyPr/>
           <a:lstStyle/>
           <a:p>
-            <a:r>
-              <a:rPr lang="en-US" dirty="0"/>
-              <a:t/>
-            </a:r>
+            <a:pPr/>
             <a:endParaRPr lang="en-US" dirty="0"/>
           </a:p>
         </p:txBody>
       </p:sp>
       <p:sp>
         <p:nvSpPr>
-          <p:cNvPr id="4" name="Slide Number Placeholder 3"/>
+          <p:cNvPr id="44" name="Slide Number Placeholder 3"/>
           <p:cNvSpPr>
             <a:spLocks noGrp="1"/>
           </p:cNvSpPr>
@@ -709,20 +709,16 @@
           <a:bodyPr/>
           <a:lstStyle/>
           <a:p>
+            <a:pPr/>
             <a:fld id="{F7021451-1387-4CA6-816F-3879F97B5CBC}" type="slidenum">
               <a:rPr lang="en-US"/>
-              <a:t>11</a:t>
+              <a:t>9</a:t>
             </a:fld>
             <a:endParaRPr lang="en-US"/>
           </a:p>
         </p:txBody>
       </p:sp>
     </p:spTree>
-    <p:extLst>
-      <p:ext uri="{BB962C8B-B14F-4D97-AF65-F5344CB8AC3E}">
-        <p14:creationId xmlns:p14="http://schemas.microsoft.com/office/powerpoint/2010/main" val="1024086991"/>
-      </p:ext>
-    </p:extLst>
   </p:cSld>
   <p:clrMapOvr>
     <a:masterClrMapping/>
@@ -731,11 +727,11 @@
 </file>
 
 <file path=ppt/notesSlides/notesSlide2.xml><?xml version="1.0" encoding="utf-8"?>
-<p:notes xmlns:a="http://schemas.openxmlformats.org/drawingml/2006/main" xmlns:r="http://schemas.openxmlformats.org/officeDocument/2006/relationships" xmlns:p="http://schemas.openxmlformats.org/presentationml/2006/main">
+<p:notes xmlns:a="http://schemas.openxmlformats.org/drawingml/2006/main" xmlns:p="http://schemas.openxmlformats.org/presentationml/2006/main">
   <p:cSld>
     <p:spTree>
       <p:nvGrpSpPr>
-        <p:cNvPr id="1" name=""/>
+        <p:cNvPr id="5" name=""/>
         <p:cNvGrpSpPr/>
         <p:nvPr/>
       </p:nvGrpSpPr>
@@ -749,7 +745,7 @@
       </p:grpSpPr>
       <p:sp>
         <p:nvSpPr>
-          <p:cNvPr id="2" name="Slide Image Placeholder 1"/>
+          <p:cNvPr id="6" name="Slide Image Placeholder 1"/>
           <p:cNvSpPr>
             <a:spLocks noGrp="1" noRot="1" noChangeAspect="1"/>
           </p:cNvSpPr>
@@ -758,10 +754,14 @@
           </p:nvPr>
         </p:nvSpPr>
         <p:spPr/>
-      </p:sp>
-      <p:sp>
-        <p:nvSpPr>
-          <p:cNvPr id="3" name="Notes Placeholder 2"/>
+        <p:txBody>
+          <a:bodyPr/>
+          <a:p/>
+        </p:txBody>
+      </p:sp>
+      <p:sp>
+        <p:nvSpPr>
+          <p:cNvPr id="7" name="Notes Placeholder 2"/>
           <p:cNvSpPr>
             <a:spLocks noGrp="1"/>
           </p:cNvSpPr>
@@ -774,17 +774,14 @@
           <a:bodyPr/>
           <a:lstStyle/>
           <a:p>
-            <a:r>
-              <a:rPr lang="en-US" dirty="0"/>
-              <a:t/>
-            </a:r>
+            <a:pPr/>
             <a:endParaRPr lang="en-US" dirty="0"/>
           </a:p>
         </p:txBody>
       </p:sp>
       <p:sp>
         <p:nvSpPr>
-          <p:cNvPr id="4" name="Slide Number Placeholder 3"/>
+          <p:cNvPr id="8" name="Slide Number Placeholder 3"/>
           <p:cNvSpPr>
             <a:spLocks noGrp="1"/>
           </p:cNvSpPr>
@@ -797,20 +794,16 @@
           <a:bodyPr/>
           <a:lstStyle/>
           <a:p>
+            <a:pPr/>
             <a:fld id="{F7021451-1387-4CA6-816F-3879F97B5CBC}" type="slidenum">
               <a:rPr lang="en-US"/>
-              <a:t>2</a:t>
+              <a:t>10</a:t>
             </a:fld>
             <a:endParaRPr lang="en-US"/>
           </a:p>
         </p:txBody>
       </p:sp>
     </p:spTree>
-    <p:extLst>
-      <p:ext uri="{BB962C8B-B14F-4D97-AF65-F5344CB8AC3E}">
-        <p14:creationId xmlns:p14="http://schemas.microsoft.com/office/powerpoint/2010/main" val="1024086991"/>
-      </p:ext>
-    </p:extLst>
   </p:cSld>
   <p:clrMapOvr>
     <a:masterClrMapping/>
@@ -819,11 +812,11 @@
 </file>
 
 <file path=ppt/notesSlides/notesSlide3.xml><?xml version="1.0" encoding="utf-8"?>
-<p:notes xmlns:a="http://schemas.openxmlformats.org/drawingml/2006/main" xmlns:r="http://schemas.openxmlformats.org/officeDocument/2006/relationships" xmlns:p="http://schemas.openxmlformats.org/presentationml/2006/main">
+<p:notes xmlns:a="http://schemas.openxmlformats.org/drawingml/2006/main" xmlns:p="http://schemas.openxmlformats.org/presentationml/2006/main">
   <p:cSld>
     <p:spTree>
       <p:nvGrpSpPr>
-        <p:cNvPr id="1" name=""/>
+        <p:cNvPr id="9" name=""/>
         <p:cNvGrpSpPr/>
         <p:nvPr/>
       </p:nvGrpSpPr>
@@ -837,7 +830,7 @@
       </p:grpSpPr>
       <p:sp>
         <p:nvSpPr>
-          <p:cNvPr id="2" name="Slide Image Placeholder 1"/>
+          <p:cNvPr id="10" name="Slide Image Placeholder 1"/>
           <p:cNvSpPr>
             <a:spLocks noGrp="1" noRot="1" noChangeAspect="1"/>
           </p:cNvSpPr>
@@ -846,10 +839,14 @@
           </p:nvPr>
         </p:nvSpPr>
         <p:spPr/>
-      </p:sp>
-      <p:sp>
-        <p:nvSpPr>
-          <p:cNvPr id="3" name="Notes Placeholder 2"/>
+        <p:txBody>
+          <a:bodyPr/>
+          <a:p/>
+        </p:txBody>
+      </p:sp>
+      <p:sp>
+        <p:nvSpPr>
+          <p:cNvPr id="11" name="Notes Placeholder 2"/>
           <p:cNvSpPr>
             <a:spLocks noGrp="1"/>
           </p:cNvSpPr>
@@ -862,17 +859,14 @@
           <a:bodyPr/>
           <a:lstStyle/>
           <a:p>
-            <a:r>
-              <a:rPr lang="en-US" dirty="0"/>
-              <a:t/>
-            </a:r>
+            <a:pPr/>
             <a:endParaRPr lang="en-US" dirty="0"/>
           </a:p>
         </p:txBody>
       </p:sp>
       <p:sp>
         <p:nvSpPr>
-          <p:cNvPr id="4" name="Slide Number Placeholder 3"/>
+          <p:cNvPr id="12" name="Slide Number Placeholder 3"/>
           <p:cNvSpPr>
             <a:spLocks noGrp="1"/>
           </p:cNvSpPr>
@@ -885,20 +879,16 @@
           <a:bodyPr/>
           <a:lstStyle/>
           <a:p>
+            <a:pPr/>
             <a:fld id="{F7021451-1387-4CA6-816F-3879F97B5CBC}" type="slidenum">
               <a:rPr lang="en-US"/>
-              <a:t>3</a:t>
+              <a:t>11</a:t>
             </a:fld>
             <a:endParaRPr lang="en-US"/>
           </a:p>
         </p:txBody>
       </p:sp>
     </p:spTree>
-    <p:extLst>
-      <p:ext uri="{BB962C8B-B14F-4D97-AF65-F5344CB8AC3E}">
-        <p14:creationId xmlns:p14="http://schemas.microsoft.com/office/powerpoint/2010/main" val="1024086991"/>
-      </p:ext>
-    </p:extLst>
   </p:cSld>
   <p:clrMapOvr>
     <a:masterClrMapping/>
@@ -907,11 +897,11 @@
 </file>
 
 <file path=ppt/notesSlides/notesSlide4.xml><?xml version="1.0" encoding="utf-8"?>
-<p:notes xmlns:a="http://schemas.openxmlformats.org/drawingml/2006/main" xmlns:r="http://schemas.openxmlformats.org/officeDocument/2006/relationships" xmlns:p="http://schemas.openxmlformats.org/presentationml/2006/main">
+<p:notes xmlns:a="http://schemas.openxmlformats.org/drawingml/2006/main" xmlns:p="http://schemas.openxmlformats.org/presentationml/2006/main">
   <p:cSld>
     <p:spTree>
       <p:nvGrpSpPr>
-        <p:cNvPr id="1" name=""/>
+        <p:cNvPr id="13" name=""/>
         <p:cNvGrpSpPr/>
         <p:nvPr/>
       </p:nvGrpSpPr>
@@ -925,7 +915,7 @@
       </p:grpSpPr>
       <p:sp>
         <p:nvSpPr>
-          <p:cNvPr id="2" name="Slide Image Placeholder 1"/>
+          <p:cNvPr id="14" name="Slide Image Placeholder 1"/>
           <p:cNvSpPr>
             <a:spLocks noGrp="1" noRot="1" noChangeAspect="1"/>
           </p:cNvSpPr>
@@ -934,10 +924,14 @@
           </p:nvPr>
         </p:nvSpPr>
         <p:spPr/>
-      </p:sp>
-      <p:sp>
-        <p:nvSpPr>
-          <p:cNvPr id="3" name="Notes Placeholder 2"/>
+        <p:txBody>
+          <a:bodyPr/>
+          <a:p/>
+        </p:txBody>
+      </p:sp>
+      <p:sp>
+        <p:nvSpPr>
+          <p:cNvPr id="15" name="Notes Placeholder 2"/>
           <p:cNvSpPr>
             <a:spLocks noGrp="1"/>
           </p:cNvSpPr>
@@ -950,17 +944,14 @@
           <a:bodyPr/>
           <a:lstStyle/>
           <a:p>
-            <a:r>
-              <a:rPr lang="en-US" dirty="0"/>
-              <a:t/>
-            </a:r>
+            <a:pPr/>
             <a:endParaRPr lang="en-US" dirty="0"/>
           </a:p>
         </p:txBody>
       </p:sp>
       <p:sp>
         <p:nvSpPr>
-          <p:cNvPr id="4" name="Slide Number Placeholder 3"/>
+          <p:cNvPr id="16" name="Slide Number Placeholder 3"/>
           <p:cNvSpPr>
             <a:spLocks noGrp="1"/>
           </p:cNvSpPr>
@@ -973,20 +964,16 @@
           <a:bodyPr/>
           <a:lstStyle/>
           <a:p>
+            <a:pPr/>
             <a:fld id="{F7021451-1387-4CA6-816F-3879F97B5CBC}" type="slidenum">
               <a:rPr lang="en-US"/>
-              <a:t>4</a:t>
+              <a:t>2</a:t>
             </a:fld>
             <a:endParaRPr lang="en-US"/>
           </a:p>
         </p:txBody>
       </p:sp>
     </p:spTree>
-    <p:extLst>
-      <p:ext uri="{BB962C8B-B14F-4D97-AF65-F5344CB8AC3E}">
-        <p14:creationId xmlns:p14="http://schemas.microsoft.com/office/powerpoint/2010/main" val="1024086991"/>
-      </p:ext>
-    </p:extLst>
   </p:cSld>
   <p:clrMapOvr>
     <a:masterClrMapping/>
@@ -995,11 +982,11 @@
 </file>
 
 <file path=ppt/notesSlides/notesSlide5.xml><?xml version="1.0" encoding="utf-8"?>
-<p:notes xmlns:a="http://schemas.openxmlformats.org/drawingml/2006/main" xmlns:r="http://schemas.openxmlformats.org/officeDocument/2006/relationships" xmlns:p="http://schemas.openxmlformats.org/presentationml/2006/main">
+<p:notes xmlns:a="http://schemas.openxmlformats.org/drawingml/2006/main" xmlns:p="http://schemas.openxmlformats.org/presentationml/2006/main">
   <p:cSld>
     <p:spTree>
       <p:nvGrpSpPr>
-        <p:cNvPr id="1" name=""/>
+        <p:cNvPr id="17" name=""/>
         <p:cNvGrpSpPr/>
         <p:nvPr/>
       </p:nvGrpSpPr>
@@ -1013,7 +1000,7 @@
       </p:grpSpPr>
       <p:sp>
         <p:nvSpPr>
-          <p:cNvPr id="2" name="Slide Image Placeholder 1"/>
+          <p:cNvPr id="18" name="Slide Image Placeholder 1"/>
           <p:cNvSpPr>
             <a:spLocks noGrp="1" noRot="1" noChangeAspect="1"/>
           </p:cNvSpPr>
@@ -1022,10 +1009,14 @@
           </p:nvPr>
         </p:nvSpPr>
         <p:spPr/>
-      </p:sp>
-      <p:sp>
-        <p:nvSpPr>
-          <p:cNvPr id="3" name="Notes Placeholder 2"/>
+        <p:txBody>
+          <a:bodyPr/>
+          <a:p/>
+        </p:txBody>
+      </p:sp>
+      <p:sp>
+        <p:nvSpPr>
+          <p:cNvPr id="19" name="Notes Placeholder 2"/>
           <p:cNvSpPr>
             <a:spLocks noGrp="1"/>
           </p:cNvSpPr>
@@ -1038,17 +1029,14 @@
           <a:bodyPr/>
           <a:lstStyle/>
           <a:p>
-            <a:r>
-              <a:rPr lang="en-US" dirty="0"/>
-              <a:t/>
-            </a:r>
+            <a:pPr/>
             <a:endParaRPr lang="en-US" dirty="0"/>
           </a:p>
         </p:txBody>
       </p:sp>
       <p:sp>
         <p:nvSpPr>
-          <p:cNvPr id="4" name="Slide Number Placeholder 3"/>
+          <p:cNvPr id="20" name="Slide Number Placeholder 3"/>
           <p:cNvSpPr>
             <a:spLocks noGrp="1"/>
           </p:cNvSpPr>
@@ -1061,20 +1049,16 @@
           <a:bodyPr/>
           <a:lstStyle/>
           <a:p>
+            <a:pPr/>
             <a:fld id="{F7021451-1387-4CA6-816F-3879F97B5CBC}" type="slidenum">
               <a:rPr lang="en-US"/>
-              <a:t>5</a:t>
+              <a:t>3</a:t>
             </a:fld>
             <a:endParaRPr lang="en-US"/>
           </a:p>
         </p:txBody>
       </p:sp>
     </p:spTree>
-    <p:extLst>
-      <p:ext uri="{BB962C8B-B14F-4D97-AF65-F5344CB8AC3E}">
-        <p14:creationId xmlns:p14="http://schemas.microsoft.com/office/powerpoint/2010/main" val="1024086991"/>
-      </p:ext>
-    </p:extLst>
   </p:cSld>
   <p:clrMapOvr>
     <a:masterClrMapping/>
@@ -1083,11 +1067,11 @@
 </file>
 
 <file path=ppt/notesSlides/notesSlide6.xml><?xml version="1.0" encoding="utf-8"?>
-<p:notes xmlns:a="http://schemas.openxmlformats.org/drawingml/2006/main" xmlns:r="http://schemas.openxmlformats.org/officeDocument/2006/relationships" xmlns:p="http://schemas.openxmlformats.org/presentationml/2006/main">
+<p:notes xmlns:a="http://schemas.openxmlformats.org/drawingml/2006/main" xmlns:p="http://schemas.openxmlformats.org/presentationml/2006/main">
   <p:cSld>
     <p:spTree>
       <p:nvGrpSpPr>
-        <p:cNvPr id="1" name=""/>
+        <p:cNvPr id="21" name=""/>
         <p:cNvGrpSpPr/>
         <p:nvPr/>
       </p:nvGrpSpPr>
@@ -1101,7 +1085,7 @@
       </p:grpSpPr>
       <p:sp>
         <p:nvSpPr>
-          <p:cNvPr id="2" name="Slide Image Placeholder 1"/>
+          <p:cNvPr id="22" name="Slide Image Placeholder 1"/>
           <p:cNvSpPr>
             <a:spLocks noGrp="1" noRot="1" noChangeAspect="1"/>
           </p:cNvSpPr>
@@ -1110,10 +1094,14 @@
           </p:nvPr>
         </p:nvSpPr>
         <p:spPr/>
-      </p:sp>
-      <p:sp>
-        <p:nvSpPr>
-          <p:cNvPr id="3" name="Notes Placeholder 2"/>
+        <p:txBody>
+          <a:bodyPr/>
+          <a:p/>
+        </p:txBody>
+      </p:sp>
+      <p:sp>
+        <p:nvSpPr>
+          <p:cNvPr id="23" name="Notes Placeholder 2"/>
           <p:cNvSpPr>
             <a:spLocks noGrp="1"/>
           </p:cNvSpPr>
@@ -1126,17 +1114,14 @@
           <a:bodyPr/>
           <a:lstStyle/>
           <a:p>
-            <a:r>
-              <a:rPr lang="en-US" dirty="0"/>
-              <a:t/>
-            </a:r>
+            <a:pPr/>
             <a:endParaRPr lang="en-US" dirty="0"/>
           </a:p>
         </p:txBody>
       </p:sp>
       <p:sp>
         <p:nvSpPr>
-          <p:cNvPr id="4" name="Slide Number Placeholder 3"/>
+          <p:cNvPr id="24" name="Slide Number Placeholder 3"/>
           <p:cNvSpPr>
             <a:spLocks noGrp="1"/>
           </p:cNvSpPr>
@@ -1149,20 +1134,16 @@
           <a:bodyPr/>
           <a:lstStyle/>
           <a:p>
+            <a:pPr/>
             <a:fld id="{F7021451-1387-4CA6-816F-3879F97B5CBC}" type="slidenum">
               <a:rPr lang="en-US"/>
-              <a:t>6</a:t>
+              <a:t>4</a:t>
             </a:fld>
             <a:endParaRPr lang="en-US"/>
           </a:p>
         </p:txBody>
       </p:sp>
     </p:spTree>
-    <p:extLst>
-      <p:ext uri="{BB962C8B-B14F-4D97-AF65-F5344CB8AC3E}">
-        <p14:creationId xmlns:p14="http://schemas.microsoft.com/office/powerpoint/2010/main" val="1024086991"/>
-      </p:ext>
-    </p:extLst>
   </p:cSld>
   <p:clrMapOvr>
     <a:masterClrMapping/>
@@ -1171,11 +1152,11 @@
 </file>
 
 <file path=ppt/notesSlides/notesSlide7.xml><?xml version="1.0" encoding="utf-8"?>
-<p:notes xmlns:a="http://schemas.openxmlformats.org/drawingml/2006/main" xmlns:r="http://schemas.openxmlformats.org/officeDocument/2006/relationships" xmlns:p="http://schemas.openxmlformats.org/presentationml/2006/main">
+<p:notes xmlns:a="http://schemas.openxmlformats.org/drawingml/2006/main" xmlns:p="http://schemas.openxmlformats.org/presentationml/2006/main">
   <p:cSld>
     <p:spTree>
       <p:nvGrpSpPr>
-        <p:cNvPr id="1" name=""/>
+        <p:cNvPr id="25" name=""/>
         <p:cNvGrpSpPr/>
         <p:nvPr/>
       </p:nvGrpSpPr>
@@ -1189,7 +1170,7 @@
       </p:grpSpPr>
       <p:sp>
         <p:nvSpPr>
-          <p:cNvPr id="2" name="Slide Image Placeholder 1"/>
+          <p:cNvPr id="26" name="Slide Image Placeholder 1"/>
           <p:cNvSpPr>
             <a:spLocks noGrp="1" noRot="1" noChangeAspect="1"/>
           </p:cNvSpPr>
@@ -1198,10 +1179,14 @@
           </p:nvPr>
         </p:nvSpPr>
         <p:spPr/>
-      </p:sp>
-      <p:sp>
-        <p:nvSpPr>
-          <p:cNvPr id="3" name="Notes Placeholder 2"/>
+        <p:txBody>
+          <a:bodyPr/>
+          <a:p/>
+        </p:txBody>
+      </p:sp>
+      <p:sp>
+        <p:nvSpPr>
+          <p:cNvPr id="27" name="Notes Placeholder 2"/>
           <p:cNvSpPr>
             <a:spLocks noGrp="1"/>
           </p:cNvSpPr>
@@ -1214,17 +1199,14 @@
           <a:bodyPr/>
           <a:lstStyle/>
           <a:p>
-            <a:r>
-              <a:rPr lang="en-US" dirty="0"/>
-              <a:t/>
-            </a:r>
+            <a:pPr/>
             <a:endParaRPr lang="en-US" dirty="0"/>
           </a:p>
         </p:txBody>
       </p:sp>
       <p:sp>
         <p:nvSpPr>
-          <p:cNvPr id="4" name="Slide Number Placeholder 3"/>
+          <p:cNvPr id="28" name="Slide Number Placeholder 3"/>
           <p:cNvSpPr>
             <a:spLocks noGrp="1"/>
           </p:cNvSpPr>
@@ -1237,20 +1219,16 @@
           <a:bodyPr/>
           <a:lstStyle/>
           <a:p>
+            <a:pPr/>
             <a:fld id="{F7021451-1387-4CA6-816F-3879F97B5CBC}" type="slidenum">
               <a:rPr lang="en-US"/>
-              <a:t>7</a:t>
+              <a:t>5</a:t>
             </a:fld>
             <a:endParaRPr lang="en-US"/>
           </a:p>
         </p:txBody>
       </p:sp>
     </p:spTree>
-    <p:extLst>
-      <p:ext uri="{BB962C8B-B14F-4D97-AF65-F5344CB8AC3E}">
-        <p14:creationId xmlns:p14="http://schemas.microsoft.com/office/powerpoint/2010/main" val="1024086991"/>
-      </p:ext>
-    </p:extLst>
   </p:cSld>
   <p:clrMapOvr>
     <a:masterClrMapping/>
@@ -1259,11 +1237,11 @@
 </file>
 
 <file path=ppt/notesSlides/notesSlide8.xml><?xml version="1.0" encoding="utf-8"?>
-<p:notes xmlns:a="http://schemas.openxmlformats.org/drawingml/2006/main" xmlns:r="http://schemas.openxmlformats.org/officeDocument/2006/relationships" xmlns:p="http://schemas.openxmlformats.org/presentationml/2006/main">
+<p:notes xmlns:a="http://schemas.openxmlformats.org/drawingml/2006/main" xmlns:p="http://schemas.openxmlformats.org/presentationml/2006/main">
   <p:cSld>
     <p:spTree>
       <p:nvGrpSpPr>
-        <p:cNvPr id="1" name=""/>
+        <p:cNvPr id="29" name=""/>
         <p:cNvGrpSpPr/>
         <p:nvPr/>
       </p:nvGrpSpPr>
@@ -1277,7 +1255,7 @@
       </p:grpSpPr>
       <p:sp>
         <p:nvSpPr>
-          <p:cNvPr id="2" name="Slide Image Placeholder 1"/>
+          <p:cNvPr id="30" name="Slide Image Placeholder 1"/>
           <p:cNvSpPr>
             <a:spLocks noGrp="1" noRot="1" noChangeAspect="1"/>
           </p:cNvSpPr>
@@ -1286,10 +1264,14 @@
           </p:nvPr>
         </p:nvSpPr>
         <p:spPr/>
-      </p:sp>
-      <p:sp>
-        <p:nvSpPr>
-          <p:cNvPr id="3" name="Notes Placeholder 2"/>
+        <p:txBody>
+          <a:bodyPr/>
+          <a:p/>
+        </p:txBody>
+      </p:sp>
+      <p:sp>
+        <p:nvSpPr>
+          <p:cNvPr id="31" name="Notes Placeholder 2"/>
           <p:cNvSpPr>
             <a:spLocks noGrp="1"/>
           </p:cNvSpPr>
@@ -1302,17 +1284,14 @@
           <a:bodyPr/>
           <a:lstStyle/>
           <a:p>
-            <a:r>
-              <a:rPr lang="en-US" dirty="0"/>
-              <a:t/>
-            </a:r>
+            <a:pPr/>
             <a:endParaRPr lang="en-US" dirty="0"/>
           </a:p>
         </p:txBody>
       </p:sp>
       <p:sp>
         <p:nvSpPr>
-          <p:cNvPr id="4" name="Slide Number Placeholder 3"/>
+          <p:cNvPr id="32" name="Slide Number Placeholder 3"/>
           <p:cNvSpPr>
             <a:spLocks noGrp="1"/>
           </p:cNvSpPr>
@@ -1325,20 +1304,16 @@
           <a:bodyPr/>
           <a:lstStyle/>
           <a:p>
+            <a:pPr/>
             <a:fld id="{F7021451-1387-4CA6-816F-3879F97B5CBC}" type="slidenum">
               <a:rPr lang="en-US"/>
-              <a:t>8</a:t>
+              <a:t>6</a:t>
             </a:fld>
             <a:endParaRPr lang="en-US"/>
           </a:p>
         </p:txBody>
       </p:sp>
     </p:spTree>
-    <p:extLst>
-      <p:ext uri="{BB962C8B-B14F-4D97-AF65-F5344CB8AC3E}">
-        <p14:creationId xmlns:p14="http://schemas.microsoft.com/office/powerpoint/2010/main" val="1024086991"/>
-      </p:ext>
-    </p:extLst>
   </p:cSld>
   <p:clrMapOvr>
     <a:masterClrMapping/>
@@ -1347,11 +1322,11 @@
 </file>
 
 <file path=ppt/notesSlides/notesSlide9.xml><?xml version="1.0" encoding="utf-8"?>
-<p:notes xmlns:a="http://schemas.openxmlformats.org/drawingml/2006/main" xmlns:r="http://schemas.openxmlformats.org/officeDocument/2006/relationships" xmlns:p="http://schemas.openxmlformats.org/presentationml/2006/main">
+<p:notes xmlns:a="http://schemas.openxmlformats.org/drawingml/2006/main" xmlns:p="http://schemas.openxmlformats.org/presentationml/2006/main">
   <p:cSld>
     <p:spTree>
       <p:nvGrpSpPr>
-        <p:cNvPr id="1" name=""/>
+        <p:cNvPr id="33" name=""/>
         <p:cNvGrpSpPr/>
         <p:nvPr/>
       </p:nvGrpSpPr>
@@ -1365,7 +1340,7 @@
       </p:grpSpPr>
       <p:sp>
         <p:nvSpPr>
-          <p:cNvPr id="2" name="Slide Image Placeholder 1"/>
+          <p:cNvPr id="34" name="Slide Image Placeholder 1"/>
           <p:cNvSpPr>
             <a:spLocks noGrp="1" noRot="1" noChangeAspect="1"/>
           </p:cNvSpPr>
@@ -1374,10 +1349,14 @@
           </p:nvPr>
         </p:nvSpPr>
         <p:spPr/>
-      </p:sp>
-      <p:sp>
-        <p:nvSpPr>
-          <p:cNvPr id="3" name="Notes Placeholder 2"/>
+        <p:txBody>
+          <a:bodyPr/>
+          <a:p/>
+        </p:txBody>
+      </p:sp>
+      <p:sp>
+        <p:nvSpPr>
+          <p:cNvPr id="35" name="Notes Placeholder 2"/>
           <p:cNvSpPr>
             <a:spLocks noGrp="1"/>
           </p:cNvSpPr>
@@ -1390,17 +1369,14 @@
           <a:bodyPr/>
           <a:lstStyle/>
           <a:p>
-            <a:r>
-              <a:rPr lang="en-US" dirty="0"/>
-              <a:t/>
-            </a:r>
+            <a:pPr/>
             <a:endParaRPr lang="en-US" dirty="0"/>
           </a:p>
         </p:txBody>
       </p:sp>
       <p:sp>
         <p:nvSpPr>
-          <p:cNvPr id="4" name="Slide Number Placeholder 3"/>
+          <p:cNvPr id="36" name="Slide Number Placeholder 3"/>
           <p:cNvSpPr>
             <a:spLocks noGrp="1"/>
           </p:cNvSpPr>
@@ -1413,20 +1389,16 @@
           <a:bodyPr/>
           <a:lstStyle/>
           <a:p>
+            <a:pPr/>
             <a:fld id="{F7021451-1387-4CA6-816F-3879F97B5CBC}" type="slidenum">
               <a:rPr lang="en-US"/>
-              <a:t>9</a:t>
+              <a:t>7</a:t>
             </a:fld>
             <a:endParaRPr lang="en-US"/>
           </a:p>
         </p:txBody>
       </p:sp>
     </p:spTree>
-    <p:extLst>
-      <p:ext uri="{BB962C8B-B14F-4D97-AF65-F5344CB8AC3E}">
-        <p14:creationId xmlns:p14="http://schemas.microsoft.com/office/powerpoint/2010/main" val="1024086991"/>
-      </p:ext>
-    </p:extLst>
   </p:cSld>
   <p:clrMapOvr>
     <a:masterClrMapping/>
@@ -1435,7 +1407,7 @@
 </file>
 
 <file path=ppt/slideLayouts/slideLayout1.xml><?xml version="1.0" encoding="utf-8"?>
-<p:sldLayout xmlns:a="http://schemas.openxmlformats.org/drawingml/2006/main" xmlns:r="http://schemas.openxmlformats.org/officeDocument/2006/relationships" xmlns:p="http://schemas.openxmlformats.org/presentationml/2006/main" preserve="1">
+<p:sldLayout xmlns:a="http://schemas.openxmlformats.org/drawingml/2006/main" xmlns:p="http://schemas.openxmlformats.org/presentationml/2006/main">
   <p:cSld name="DEFAULT">
     <p:bg>
       <p:bgRef idx="1001">
@@ -1485,14 +1457,14 @@
   </p:cSld>
   <p:clrMap bg1="lt1" tx1="dk1" bg2="lt2" tx2="dk2" accent1="accent1" accent2="accent2" accent3="accent3" accent4="accent4" accent5="accent5" accent6="accent6" hlink="hlink" folHlink="folHlink"/>
   <p:sldLayoutIdLst>
-    <p:sldLayoutId id="2147483649" r:id="rId1"/>
+    <p:sldLayoutId id="2147483649" r:id="rId0"/>
   </p:sldLayoutIdLst>
   <p:hf sldNum="0" hdr="0" ftr="0" dt="0"/>
   <p:txStyles>
     <p:titleStyle>
       <a:lvl1pPr algn="ctr" defTabSz="914400" rtl="0" eaLnBrk="1" latinLnBrk="0" hangingPunct="1">
         <a:spcBef>
-          <a:spcPct val="0"/>
+          <a:spcPct val="1"/>
         </a:spcBef>
         <a:buNone/>
         <a:defRPr sz="4400" kern="1200">
@@ -1742,7 +1714,7 @@
 </file>
 
 <file path=ppt/slides/slide1.xml><?xml version="1.0" encoding="utf-8"?>
-<p:sld xmlns:a="http://schemas.openxmlformats.org/drawingml/2006/main" xmlns:r="http://schemas.openxmlformats.org/officeDocument/2006/relationships" xmlns:p="http://schemas.openxmlformats.org/presentationml/2006/main">
+<p:sld xmlns:a="http://schemas.openxmlformats.org/drawingml/2006/main" xmlns:p="http://schemas.openxmlformats.org/presentationml/2006/main">
   <p:cSld name="Slide 1">
     <p:bg>
       <p:bgPr>
@@ -1784,6 +1756,10 @@
           </a:solidFill>
           <a:ln/>
         </p:spPr>
+        <p:txBody>
+          <a:bodyPr/>
+          <a:p/>
+        </p:txBody>
       </p:sp>
       <p:sp>
         <p:nvSpPr>
@@ -1806,7 +1782,7 @@
           <a:bodyPr wrap="square" rtlCol="0" anchor="ctr"/>
           <a:lstStyle/>
           <a:p>
-            <a:pPr indent="0" marL="0">
+            <a:pPr marL="0" indent="0">
               <a:buNone/>
             </a:pPr>
             <a:r>
@@ -1831,21 +1807,21 @@
           <p:nvPr/>
         </p:nvSpPr>
         <p:spPr>
-          <a:xfrm>
-            <a:off x="731520" y="1920240"/>
-            <a:ext cx="7680960" cy="548640"/>
-          </a:xfrm>
-          <a:prstGeom prst="rect">
-            <a:avLst/>
-          </a:prstGeom>
-          <a:noFill/>
-          <a:ln/>
-        </p:spPr>
-        <p:txBody>
-          <a:bodyPr wrap="square" rtlCol="0" anchor="ctr"/>
-          <a:lstStyle/>
-          <a:p>
-            <a:pPr indent="0" marL="0">
+          <a:xfrm rot="0" flipH="0" flipV="0">
+            <a:off x="731520" y="2194560"/>
+            <a:ext cx="7680959" cy="548640"/>
+          </a:xfrm>
+          <a:prstGeom prst="rect">
+            <a:avLst/>
+          </a:prstGeom>
+          <a:noFill/>
+          <a:ln/>
+        </p:spPr>
+        <p:txBody>
+          <a:bodyPr wrap="square" rtlCol="0" anchor="ctr"/>
+          <a:lstStyle/>
+          <a:p>
+            <a:pPr marL="0" indent="0">
               <a:buNone/>
             </a:pPr>
             <a:r>
@@ -1884,7 +1860,7 @@
           <a:bodyPr wrap="square" rtlCol="0" anchor="ctr"/>
           <a:lstStyle/>
           <a:p>
-            <a:pPr indent="0" marL="0">
+            <a:pPr marL="0" indent="0">
               <a:buNone/>
             </a:pPr>
             <a:r>
@@ -1923,7 +1899,7 @@
           <a:bodyPr wrap="square" rtlCol="0" anchor="ctr"/>
           <a:lstStyle/>
           <a:p>
-            <a:pPr indent="0" marL="0">
+            <a:pPr marL="0" indent="0">
               <a:buNone/>
             </a:pPr>
             <a:r>
@@ -1962,7 +1938,7 @@
           <a:bodyPr wrap="square" rtlCol="0" anchor="ctr"/>
           <a:lstStyle/>
           <a:p>
-            <a:pPr indent="0" marL="0">
+            <a:pPr marL="0" indent="0">
               <a:buNone/>
             </a:pPr>
             <a:r>
@@ -1989,7 +1965,7 @@
 </file>
 
 <file path=ppt/slides/slide10.xml><?xml version="1.0" encoding="utf-8"?>
-<p:sld xmlns:a="http://schemas.openxmlformats.org/drawingml/2006/main" xmlns:r="http://schemas.openxmlformats.org/officeDocument/2006/relationships" xmlns:p="http://schemas.openxmlformats.org/presentationml/2006/main">
+<p:sld xmlns:a="http://schemas.openxmlformats.org/drawingml/2006/main" xmlns:p="http://schemas.openxmlformats.org/presentationml/2006/main">
   <p:cSld name="Slide 10">
     <p:bg>
       <p:bgPr>
@@ -2000,7 +1976,7 @@
     </p:bg>
     <p:spTree>
       <p:nvGrpSpPr>
-        <p:cNvPr id="1" name=""/>
+        <p:cNvPr id="8" name=""/>
         <p:cNvGrpSpPr/>
         <p:nvPr/>
       </p:nvGrpSpPr>
@@ -2014,7 +1990,7 @@
       </p:grpSpPr>
       <p:sp>
         <p:nvSpPr>
-          <p:cNvPr id="2" name="Text 0"/>
+          <p:cNvPr id="9" name="Text 0"/>
           <p:cNvSpPr/>
           <p:nvPr/>
         </p:nvSpPr>
@@ -2033,7 +2009,7 @@
           <a:bodyPr wrap="square" rtlCol="0" anchor="ctr"/>
           <a:lstStyle/>
           <a:p>
-            <a:pPr indent="0" marL="0">
+            <a:pPr marL="0" indent="0">
               <a:buNone/>
             </a:pPr>
             <a:r>
@@ -2053,7 +2029,7 @@
       </p:sp>
       <p:sp>
         <p:nvSpPr>
-          <p:cNvPr id="3" name="Shape 1"/>
+          <p:cNvPr id="10" name="Shape 1"/>
           <p:cNvSpPr/>
           <p:nvPr/>
         </p:nvSpPr>
@@ -2077,10 +2053,14 @@
             <a:prstDash val="solid"/>
           </a:ln>
         </p:spPr>
-      </p:sp>
-      <p:sp>
-        <p:nvSpPr>
-          <p:cNvPr id="4" name="Text 2"/>
+        <p:txBody>
+          <a:bodyPr/>
+          <a:p/>
+        </p:txBody>
+      </p:sp>
+      <p:sp>
+        <p:nvSpPr>
+          <p:cNvPr id="11" name="Text 2"/>
           <p:cNvSpPr/>
           <p:nvPr/>
         </p:nvSpPr>
@@ -2099,7 +2079,7 @@
           <a:bodyPr wrap="square" rtlCol="0" anchor="ctr"/>
           <a:lstStyle/>
           <a:p>
-            <a:pPr indent="0" marL="0">
+            <a:pPr marL="0" indent="0">
               <a:buNone/>
             </a:pPr>
             <a:r>
@@ -2119,7 +2099,7 @@
       </p:sp>
       <p:sp>
         <p:nvSpPr>
-          <p:cNvPr id="5" name="Text 3"/>
+          <p:cNvPr id="12" name="Text 3"/>
           <p:cNvSpPr/>
           <p:nvPr/>
         </p:nvSpPr>
@@ -2138,7 +2118,7 @@
           <a:bodyPr wrap="square" rtlCol="0" anchor="ctr"/>
           <a:lstStyle/>
           <a:p>
-            <a:pPr indent="0" marL="0">
+            <a:pPr marL="0" indent="0">
               <a:buNone/>
             </a:pPr>
             <a:r>
@@ -2158,7 +2138,7 @@
       </p:sp>
       <p:sp>
         <p:nvSpPr>
-          <p:cNvPr id="6" name="Shape 4"/>
+          <p:cNvPr id="13" name="Shape 4"/>
           <p:cNvSpPr/>
           <p:nvPr/>
         </p:nvSpPr>
@@ -2182,10 +2162,14 @@
             <a:prstDash val="solid"/>
           </a:ln>
         </p:spPr>
-      </p:sp>
-      <p:sp>
-        <p:nvSpPr>
-          <p:cNvPr id="7" name="Text 5"/>
+        <p:txBody>
+          <a:bodyPr/>
+          <a:p/>
+        </p:txBody>
+      </p:sp>
+      <p:sp>
+        <p:nvSpPr>
+          <p:cNvPr id="14" name="Text 5"/>
           <p:cNvSpPr/>
           <p:nvPr/>
         </p:nvSpPr>
@@ -2204,7 +2188,7 @@
           <a:bodyPr wrap="square" rtlCol="0" anchor="ctr"/>
           <a:lstStyle/>
           <a:p>
-            <a:pPr indent="0" marL="0">
+            <a:pPr marL="0" indent="0">
               <a:buNone/>
             </a:pPr>
             <a:r>
@@ -2224,7 +2208,7 @@
       </p:sp>
       <p:sp>
         <p:nvSpPr>
-          <p:cNvPr id="8" name="Text 6"/>
+          <p:cNvPr id="15" name="Text 6"/>
           <p:cNvSpPr/>
           <p:nvPr/>
         </p:nvSpPr>
@@ -2243,7 +2227,7 @@
           <a:bodyPr wrap="square" rtlCol="0" anchor="ctr"/>
           <a:lstStyle/>
           <a:p>
-            <a:pPr indent="0" marL="0">
+            <a:pPr marL="0" indent="0">
               <a:buNone/>
             </a:pPr>
             <a:r>
@@ -2263,7 +2247,7 @@
       </p:sp>
       <p:sp>
         <p:nvSpPr>
-          <p:cNvPr id="9" name="Shape 7"/>
+          <p:cNvPr id="16" name="Shape 7"/>
           <p:cNvSpPr/>
           <p:nvPr/>
         </p:nvSpPr>
@@ -2287,10 +2271,14 @@
             <a:prstDash val="solid"/>
           </a:ln>
         </p:spPr>
-      </p:sp>
-      <p:sp>
-        <p:nvSpPr>
-          <p:cNvPr id="10" name="Text 8"/>
+        <p:txBody>
+          <a:bodyPr/>
+          <a:p/>
+        </p:txBody>
+      </p:sp>
+      <p:sp>
+        <p:nvSpPr>
+          <p:cNvPr id="17" name="Text 8"/>
           <p:cNvSpPr/>
           <p:nvPr/>
         </p:nvSpPr>
@@ -2309,7 +2297,7 @@
           <a:bodyPr wrap="square" rtlCol="0" anchor="ctr"/>
           <a:lstStyle/>
           <a:p>
-            <a:pPr indent="0" marL="0">
+            <a:pPr marL="0" indent="0">
               <a:buNone/>
             </a:pPr>
             <a:r>
@@ -2329,7 +2317,7 @@
       </p:sp>
       <p:sp>
         <p:nvSpPr>
-          <p:cNvPr id="11" name="Text 9"/>
+          <p:cNvPr id="18" name="Text 9"/>
           <p:cNvSpPr/>
           <p:nvPr/>
         </p:nvSpPr>
@@ -2348,7 +2336,7 @@
           <a:bodyPr wrap="square" rtlCol="0" anchor="ctr"/>
           <a:lstStyle/>
           <a:p>
-            <a:pPr indent="0" marL="0">
+            <a:pPr marL="0" indent="0">
               <a:buNone/>
             </a:pPr>
             <a:r>
@@ -2368,7 +2356,7 @@
       </p:sp>
       <p:sp>
         <p:nvSpPr>
-          <p:cNvPr id="12" name="Shape 10"/>
+          <p:cNvPr id="19" name="Shape 10"/>
           <p:cNvSpPr/>
           <p:nvPr/>
         </p:nvSpPr>
@@ -2385,10 +2373,14 @@
           </a:solidFill>
           <a:ln/>
         </p:spPr>
-      </p:sp>
-      <p:sp>
-        <p:nvSpPr>
-          <p:cNvPr id="13" name="Text 11"/>
+        <p:txBody>
+          <a:bodyPr/>
+          <a:p/>
+        </p:txBody>
+      </p:sp>
+      <p:sp>
+        <p:nvSpPr>
+          <p:cNvPr id="20" name="Text 11"/>
           <p:cNvSpPr/>
           <p:nvPr/>
         </p:nvSpPr>
@@ -2407,7 +2399,7 @@
           <a:bodyPr wrap="square" rtlCol="0" anchor="ctr"/>
           <a:lstStyle/>
           <a:p>
-            <a:pPr algn="ctr" indent="0" marL="0">
+            <a:pPr marL="0" indent="0" algn="ctr">
               <a:buNone/>
             </a:pPr>
             <a:r>
@@ -2434,7 +2426,7 @@
 </file>
 
 <file path=ppt/slides/slide11.xml><?xml version="1.0" encoding="utf-8"?>
-<p:sld xmlns:a="http://schemas.openxmlformats.org/drawingml/2006/main" xmlns:r="http://schemas.openxmlformats.org/officeDocument/2006/relationships" xmlns:p="http://schemas.openxmlformats.org/presentationml/2006/main">
+<p:sld xmlns:a="http://schemas.openxmlformats.org/drawingml/2006/main" xmlns:p="http://schemas.openxmlformats.org/presentationml/2006/main">
   <p:cSld name="Slide 11">
     <p:bg>
       <p:bgPr>
@@ -2445,7 +2437,7 @@
     </p:bg>
     <p:spTree>
       <p:nvGrpSpPr>
-        <p:cNvPr id="1" name=""/>
+        <p:cNvPr id="21" name=""/>
         <p:cNvGrpSpPr/>
         <p:nvPr/>
       </p:nvGrpSpPr>
@@ -2459,7 +2451,7 @@
       </p:grpSpPr>
       <p:sp>
         <p:nvSpPr>
-          <p:cNvPr id="2" name="Shape 0"/>
+          <p:cNvPr id="22" name="Shape 0"/>
           <p:cNvSpPr/>
           <p:nvPr/>
         </p:nvSpPr>
@@ -2476,10 +2468,14 @@
           </a:solidFill>
           <a:ln/>
         </p:spPr>
-      </p:sp>
-      <p:sp>
-        <p:nvSpPr>
-          <p:cNvPr id="3" name="Text 1"/>
+        <p:txBody>
+          <a:bodyPr/>
+          <a:p/>
+        </p:txBody>
+      </p:sp>
+      <p:sp>
+        <p:nvSpPr>
+          <p:cNvPr id="23" name="Text 1"/>
           <p:cNvSpPr/>
           <p:nvPr/>
         </p:nvSpPr>
@@ -2498,7 +2494,7 @@
           <a:bodyPr wrap="square" rtlCol="0" anchor="ctr"/>
           <a:lstStyle/>
           <a:p>
-            <a:pPr indent="0" marL="0">
+            <a:pPr marL="0" indent="0">
               <a:buNone/>
             </a:pPr>
             <a:r>
@@ -2518,7 +2514,7 @@
       </p:sp>
       <p:sp>
         <p:nvSpPr>
-          <p:cNvPr id="4" name="Text 2"/>
+          <p:cNvPr id="24" name="Text 2"/>
           <p:cNvSpPr/>
           <p:nvPr/>
         </p:nvSpPr>
@@ -2537,7 +2533,7 @@
           <a:bodyPr wrap="square" rtlCol="0" anchor="ctr"/>
           <a:lstStyle/>
           <a:p>
-            <a:pPr indent="0" marL="0">
+            <a:pPr marL="0" indent="0">
               <a:buNone/>
             </a:pPr>
             <a:r>
@@ -2557,7 +2553,7 @@
       </p:sp>
       <p:sp>
         <p:nvSpPr>
-          <p:cNvPr id="5" name="Text 3"/>
+          <p:cNvPr id="25" name="Text 3"/>
           <p:cNvSpPr/>
           <p:nvPr/>
         </p:nvSpPr>
@@ -2576,7 +2572,7 @@
           <a:bodyPr wrap="square" rtlCol="0" anchor="ctr"/>
           <a:lstStyle/>
           <a:p>
-            <a:pPr indent="0" marL="0">
+            <a:pPr marL="0" indent="0">
               <a:buNone/>
             </a:pPr>
             <a:r>
@@ -2596,7 +2592,7 @@
       </p:sp>
       <p:sp>
         <p:nvSpPr>
-          <p:cNvPr id="6" name="Text 4"/>
+          <p:cNvPr id="26" name="Text 4"/>
           <p:cNvSpPr/>
           <p:nvPr/>
         </p:nvSpPr>
@@ -2615,7 +2611,7 @@
           <a:bodyPr wrap="square" rtlCol="0" anchor="ctr"/>
           <a:lstStyle/>
           <a:p>
-            <a:pPr indent="0" marL="0">
+            <a:pPr marL="0" indent="0">
               <a:buNone/>
             </a:pPr>
             <a:r>
@@ -2635,7 +2631,7 @@
       </p:sp>
       <p:sp>
         <p:nvSpPr>
-          <p:cNvPr id="7" name="Text 5"/>
+          <p:cNvPr id="27" name="Text 5"/>
           <p:cNvSpPr/>
           <p:nvPr/>
         </p:nvSpPr>
@@ -2654,7 +2650,7 @@
           <a:bodyPr wrap="square" rtlCol="0" anchor="ctr"/>
           <a:lstStyle/>
           <a:p>
-            <a:pPr indent="0" marL="0">
+            <a:pPr marL="0" indent="0">
               <a:buNone/>
             </a:pPr>
             <a:r>
@@ -2674,7 +2670,7 @@
       </p:sp>
       <p:sp>
         <p:nvSpPr>
-          <p:cNvPr id="8" name="Text 6"/>
+          <p:cNvPr id="28" name="Text 6"/>
           <p:cNvSpPr/>
           <p:nvPr/>
         </p:nvSpPr>
@@ -2693,7 +2689,7 @@
           <a:bodyPr wrap="square" rtlCol="0" anchor="ctr"/>
           <a:lstStyle/>
           <a:p>
-            <a:pPr indent="0" marL="0">
+            <a:pPr marL="0" indent="0">
               <a:buNone/>
             </a:pPr>
             <a:r>
@@ -2713,7 +2709,7 @@
       </p:sp>
       <p:sp>
         <p:nvSpPr>
-          <p:cNvPr id="9" name="Text 7"/>
+          <p:cNvPr id="29" name="Text 7"/>
           <p:cNvSpPr/>
           <p:nvPr/>
         </p:nvSpPr>
@@ -2732,7 +2728,7 @@
           <a:bodyPr wrap="square" rtlCol="0" anchor="ctr"/>
           <a:lstStyle/>
           <a:p>
-            <a:pPr indent="0" marL="0">
+            <a:pPr marL="0" indent="0">
               <a:buNone/>
             </a:pPr>
             <a:r>
@@ -2752,7 +2748,7 @@
       </p:sp>
       <p:sp>
         <p:nvSpPr>
-          <p:cNvPr id="10" name="Text 8"/>
+          <p:cNvPr id="30" name="Text 8"/>
           <p:cNvSpPr/>
           <p:nvPr/>
         </p:nvSpPr>
@@ -2771,7 +2767,7 @@
           <a:bodyPr wrap="square" rtlCol="0" anchor="ctr"/>
           <a:lstStyle/>
           <a:p>
-            <a:pPr indent="0" marL="0">
+            <a:pPr marL="0" indent="0">
               <a:buNone/>
             </a:pPr>
             <a:r>
@@ -2791,7 +2787,7 @@
       </p:sp>
       <p:sp>
         <p:nvSpPr>
-          <p:cNvPr id="11" name="Text 9"/>
+          <p:cNvPr id="31" name="Text 9"/>
           <p:cNvSpPr/>
           <p:nvPr/>
         </p:nvSpPr>
@@ -2810,7 +2806,7 @@
           <a:bodyPr wrap="square" rtlCol="0" anchor="ctr"/>
           <a:lstStyle/>
           <a:p>
-            <a:pPr indent="0" marL="0">
+            <a:pPr marL="0" indent="0">
               <a:buNone/>
             </a:pPr>
             <a:r>
@@ -2830,7 +2826,7 @@
       </p:sp>
       <p:sp>
         <p:nvSpPr>
-          <p:cNvPr id="12" name="Text 10"/>
+          <p:cNvPr id="32" name="Text 10"/>
           <p:cNvSpPr/>
           <p:nvPr/>
         </p:nvSpPr>
@@ -2849,7 +2845,7 @@
           <a:bodyPr wrap="square" rtlCol="0" anchor="ctr"/>
           <a:lstStyle/>
           <a:p>
-            <a:pPr indent="0" marL="0">
+            <a:pPr marL="0" indent="0">
               <a:buNone/>
             </a:pPr>
             <a:r>
@@ -2876,7 +2872,7 @@
 </file>
 
 <file path=ppt/slides/slide2.xml><?xml version="1.0" encoding="utf-8"?>
-<p:sld xmlns:a="http://schemas.openxmlformats.org/drawingml/2006/main" xmlns:r="http://schemas.openxmlformats.org/officeDocument/2006/relationships" xmlns:p="http://schemas.openxmlformats.org/presentationml/2006/main">
+<p:sld xmlns:a="http://schemas.openxmlformats.org/drawingml/2006/main" xmlns:p="http://schemas.openxmlformats.org/presentationml/2006/main">
   <p:cSld name="Slide 2">
     <p:bg>
       <p:bgPr>
@@ -2887,7 +2883,7 @@
     </p:bg>
     <p:spTree>
       <p:nvGrpSpPr>
-        <p:cNvPr id="1" name=""/>
+        <p:cNvPr id="33" name=""/>
         <p:cNvGrpSpPr/>
         <p:nvPr/>
       </p:nvGrpSpPr>
@@ -2901,7 +2897,7 @@
       </p:grpSpPr>
       <p:sp>
         <p:nvSpPr>
-          <p:cNvPr id="2" name="Text 0"/>
+          <p:cNvPr id="34" name="Text 0"/>
           <p:cNvSpPr/>
           <p:nvPr/>
         </p:nvSpPr>
@@ -2920,7 +2916,7 @@
           <a:bodyPr wrap="square" rtlCol="0" anchor="ctr"/>
           <a:lstStyle/>
           <a:p>
-            <a:pPr indent="0" marL="0">
+            <a:pPr marL="0" indent="0">
               <a:buNone/>
             </a:pPr>
             <a:r>
@@ -2940,7 +2936,7 @@
       </p:sp>
       <p:sp>
         <p:nvSpPr>
-          <p:cNvPr id="3" name="Text 1"/>
+          <p:cNvPr id="35" name="Text 1"/>
           <p:cNvSpPr/>
           <p:nvPr/>
         </p:nvSpPr>
@@ -2959,7 +2955,7 @@
           <a:bodyPr wrap="square" rtlCol="0" anchor="ctr"/>
           <a:lstStyle/>
           <a:p>
-            <a:pPr indent="0" marL="0">
+            <a:pPr marL="0" indent="0">
               <a:buNone/>
             </a:pPr>
             <a:r>
@@ -2979,7 +2975,7 @@
       </p:sp>
       <p:sp>
         <p:nvSpPr>
-          <p:cNvPr id="4" name="Shape 2"/>
+          <p:cNvPr id="36" name="Shape 2"/>
           <p:cNvSpPr/>
           <p:nvPr/>
         </p:nvSpPr>
@@ -3003,10 +2999,14 @@
             <a:prstDash val="solid"/>
           </a:ln>
         </p:spPr>
-      </p:sp>
-      <p:sp>
-        <p:nvSpPr>
-          <p:cNvPr id="5" name="Text 3"/>
+        <p:txBody>
+          <a:bodyPr/>
+          <a:p/>
+        </p:txBody>
+      </p:sp>
+      <p:sp>
+        <p:nvSpPr>
+          <p:cNvPr id="37" name="Text 3"/>
           <p:cNvSpPr/>
           <p:nvPr/>
         </p:nvSpPr>
@@ -3025,7 +3025,7 @@
           <a:bodyPr wrap="square" rtlCol="0" anchor="ctr"/>
           <a:lstStyle/>
           <a:p>
-            <a:pPr algn="ctr" indent="0" marL="0">
+            <a:pPr marL="0" indent="0" algn="ctr">
               <a:buNone/>
             </a:pPr>
             <a:r>
@@ -3045,7 +3045,7 @@
       </p:sp>
       <p:sp>
         <p:nvSpPr>
-          <p:cNvPr id="6" name="Text 4"/>
+          <p:cNvPr id="38" name="Text 4"/>
           <p:cNvSpPr/>
           <p:nvPr/>
         </p:nvSpPr>
@@ -3064,7 +3064,7 @@
           <a:bodyPr wrap="square" rtlCol="0" anchor="ctr"/>
           <a:lstStyle/>
           <a:p>
-            <a:pPr indent="0" marL="0">
+            <a:pPr marL="0" indent="0">
               <a:buNone/>
             </a:pPr>
             <a:r>
@@ -3084,7 +3084,7 @@
       </p:sp>
       <p:sp>
         <p:nvSpPr>
-          <p:cNvPr id="7" name="Shape 5"/>
+          <p:cNvPr id="39" name="Shape 5"/>
           <p:cNvSpPr/>
           <p:nvPr/>
         </p:nvSpPr>
@@ -3108,10 +3108,14 @@
             <a:prstDash val="solid"/>
           </a:ln>
         </p:spPr>
-      </p:sp>
-      <p:sp>
-        <p:nvSpPr>
-          <p:cNvPr id="8" name="Text 6"/>
+        <p:txBody>
+          <a:bodyPr/>
+          <a:p/>
+        </p:txBody>
+      </p:sp>
+      <p:sp>
+        <p:nvSpPr>
+          <p:cNvPr id="40" name="Text 6"/>
           <p:cNvSpPr/>
           <p:nvPr/>
         </p:nvSpPr>
@@ -3130,7 +3134,7 @@
           <a:bodyPr wrap="square" rtlCol="0" anchor="ctr"/>
           <a:lstStyle/>
           <a:p>
-            <a:pPr algn="ctr" indent="0" marL="0">
+            <a:pPr marL="0" indent="0" algn="ctr">
               <a:buNone/>
             </a:pPr>
             <a:r>
@@ -3150,7 +3154,7 @@
       </p:sp>
       <p:sp>
         <p:nvSpPr>
-          <p:cNvPr id="9" name="Text 7"/>
+          <p:cNvPr id="41" name="Text 7"/>
           <p:cNvSpPr/>
           <p:nvPr/>
         </p:nvSpPr>
@@ -3169,7 +3173,7 @@
           <a:bodyPr wrap="square" rtlCol="0" anchor="ctr"/>
           <a:lstStyle/>
           <a:p>
-            <a:pPr indent="0" marL="0">
+            <a:pPr marL="0" indent="0">
               <a:buNone/>
             </a:pPr>
             <a:r>
@@ -3189,7 +3193,7 @@
       </p:sp>
       <p:sp>
         <p:nvSpPr>
-          <p:cNvPr id="10" name="Shape 8"/>
+          <p:cNvPr id="42" name="Shape 8"/>
           <p:cNvSpPr/>
           <p:nvPr/>
         </p:nvSpPr>
@@ -3213,10 +3217,14 @@
             <a:prstDash val="solid"/>
           </a:ln>
         </p:spPr>
-      </p:sp>
-      <p:sp>
-        <p:nvSpPr>
-          <p:cNvPr id="11" name="Text 9"/>
+        <p:txBody>
+          <a:bodyPr/>
+          <a:p/>
+        </p:txBody>
+      </p:sp>
+      <p:sp>
+        <p:nvSpPr>
+          <p:cNvPr id="43" name="Text 9"/>
           <p:cNvSpPr/>
           <p:nvPr/>
         </p:nvSpPr>
@@ -3235,7 +3243,7 @@
           <a:bodyPr wrap="square" rtlCol="0" anchor="ctr"/>
           <a:lstStyle/>
           <a:p>
-            <a:pPr algn="ctr" indent="0" marL="0">
+            <a:pPr marL="0" indent="0" algn="ctr">
               <a:buNone/>
             </a:pPr>
             <a:r>
@@ -3255,7 +3263,7 @@
       </p:sp>
       <p:sp>
         <p:nvSpPr>
-          <p:cNvPr id="12" name="Text 10"/>
+          <p:cNvPr id="44" name="Text 10"/>
           <p:cNvSpPr/>
           <p:nvPr/>
         </p:nvSpPr>
@@ -3274,7 +3282,7 @@
           <a:bodyPr wrap="square" rtlCol="0" anchor="ctr"/>
           <a:lstStyle/>
           <a:p>
-            <a:pPr indent="0" marL="0">
+            <a:pPr marL="0" indent="0">
               <a:buNone/>
             </a:pPr>
             <a:r>
@@ -3294,7 +3302,7 @@
       </p:sp>
       <p:sp>
         <p:nvSpPr>
-          <p:cNvPr id="13" name="Shape 11"/>
+          <p:cNvPr id="45" name="Shape 11"/>
           <p:cNvSpPr/>
           <p:nvPr/>
         </p:nvSpPr>
@@ -3318,10 +3326,14 @@
             <a:prstDash val="solid"/>
           </a:ln>
         </p:spPr>
-      </p:sp>
-      <p:sp>
-        <p:nvSpPr>
-          <p:cNvPr id="14" name="Text 12"/>
+        <p:txBody>
+          <a:bodyPr/>
+          <a:p/>
+        </p:txBody>
+      </p:sp>
+      <p:sp>
+        <p:nvSpPr>
+          <p:cNvPr id="46" name="Text 12"/>
           <p:cNvSpPr/>
           <p:nvPr/>
         </p:nvSpPr>
@@ -3340,7 +3352,7 @@
           <a:bodyPr wrap="square" rtlCol="0" anchor="ctr"/>
           <a:lstStyle/>
           <a:p>
-            <a:pPr algn="ctr" indent="0" marL="0">
+            <a:pPr marL="0" indent="0" algn="ctr">
               <a:buNone/>
             </a:pPr>
             <a:r>
@@ -3360,7 +3372,7 @@
       </p:sp>
       <p:sp>
         <p:nvSpPr>
-          <p:cNvPr id="15" name="Text 13"/>
+          <p:cNvPr id="47" name="Text 13"/>
           <p:cNvSpPr/>
           <p:nvPr/>
         </p:nvSpPr>
@@ -3379,7 +3391,7 @@
           <a:bodyPr wrap="square" rtlCol="0" anchor="ctr"/>
           <a:lstStyle/>
           <a:p>
-            <a:pPr indent="0" marL="0">
+            <a:pPr marL="0" indent="0">
               <a:buNone/>
             </a:pPr>
             <a:r>
@@ -3399,7 +3411,7 @@
       </p:sp>
       <p:sp>
         <p:nvSpPr>
-          <p:cNvPr id="16" name="Shape 14"/>
+          <p:cNvPr id="48" name="Shape 14"/>
           <p:cNvSpPr/>
           <p:nvPr/>
         </p:nvSpPr>
@@ -3423,10 +3435,14 @@
             <a:prstDash val="solid"/>
           </a:ln>
         </p:spPr>
-      </p:sp>
-      <p:sp>
-        <p:nvSpPr>
-          <p:cNvPr id="17" name="Text 15"/>
+        <p:txBody>
+          <a:bodyPr/>
+          <a:p/>
+        </p:txBody>
+      </p:sp>
+      <p:sp>
+        <p:nvSpPr>
+          <p:cNvPr id="49" name="Text 15"/>
           <p:cNvSpPr/>
           <p:nvPr/>
         </p:nvSpPr>
@@ -3445,7 +3461,7 @@
           <a:bodyPr wrap="square" rtlCol="0" anchor="ctr"/>
           <a:lstStyle/>
           <a:p>
-            <a:pPr algn="ctr" indent="0" marL="0">
+            <a:pPr marL="0" indent="0" algn="ctr">
               <a:buNone/>
             </a:pPr>
             <a:r>
@@ -3465,7 +3481,7 @@
       </p:sp>
       <p:sp>
         <p:nvSpPr>
-          <p:cNvPr id="18" name="Shape 16"/>
+          <p:cNvPr id="50" name="Shape 16"/>
           <p:cNvSpPr/>
           <p:nvPr/>
         </p:nvSpPr>
@@ -3484,10 +3500,14 @@
           </a:solidFill>
           <a:ln/>
         </p:spPr>
-      </p:sp>
-      <p:sp>
-        <p:nvSpPr>
-          <p:cNvPr id="19" name="Text 17"/>
+        <p:txBody>
+          <a:bodyPr/>
+          <a:p/>
+        </p:txBody>
+      </p:sp>
+      <p:sp>
+        <p:nvSpPr>
+          <p:cNvPr id="51" name="Text 17"/>
           <p:cNvSpPr/>
           <p:nvPr/>
         </p:nvSpPr>
@@ -3506,7 +3526,7 @@
           <a:bodyPr wrap="square" rtlCol="0" anchor="ctr"/>
           <a:lstStyle/>
           <a:p>
-            <a:pPr algn="ctr" indent="0" marL="0">
+            <a:pPr marL="0" indent="0" algn="ctr">
               <a:buNone/>
             </a:pPr>
             <a:r>
@@ -3526,7 +3546,7 @@
       </p:sp>
       <p:sp>
         <p:nvSpPr>
-          <p:cNvPr id="20" name="Text 18"/>
+          <p:cNvPr id="52" name="Text 18"/>
           <p:cNvSpPr/>
           <p:nvPr/>
         </p:nvSpPr>
@@ -3545,7 +3565,7 @@
           <a:bodyPr wrap="square" rtlCol="0" anchor="ctr"/>
           <a:lstStyle/>
           <a:p>
-            <a:pPr indent="0" marL="0">
+            <a:pPr marL="0" indent="0">
               <a:buNone/>
             </a:pPr>
             <a:r>
@@ -3565,7 +3585,7 @@
       </p:sp>
       <p:sp>
         <p:nvSpPr>
-          <p:cNvPr id="21" name="Shape 19"/>
+          <p:cNvPr id="53" name="Shape 19"/>
           <p:cNvSpPr/>
           <p:nvPr/>
         </p:nvSpPr>
@@ -3582,10 +3602,14 @@
           </a:solidFill>
           <a:ln/>
         </p:spPr>
-      </p:sp>
-      <p:sp>
-        <p:nvSpPr>
-          <p:cNvPr id="22" name="Text 20"/>
+        <p:txBody>
+          <a:bodyPr/>
+          <a:p/>
+        </p:txBody>
+      </p:sp>
+      <p:sp>
+        <p:nvSpPr>
+          <p:cNvPr id="54" name="Text 20"/>
           <p:cNvSpPr/>
           <p:nvPr/>
         </p:nvSpPr>
@@ -3604,7 +3628,7 @@
           <a:bodyPr wrap="square" rtlCol="0" anchor="ctr"/>
           <a:lstStyle/>
           <a:p>
-            <a:pPr algn="ctr" indent="0" marL="0">
+            <a:pPr marL="0" indent="0" algn="ctr">
               <a:buNone/>
             </a:pPr>
             <a:r>
@@ -3631,7 +3655,7 @@
 </file>
 
 <file path=ppt/slides/slide3.xml><?xml version="1.0" encoding="utf-8"?>
-<p:sld xmlns:a="http://schemas.openxmlformats.org/drawingml/2006/main" xmlns:r="http://schemas.openxmlformats.org/officeDocument/2006/relationships" xmlns:p="http://schemas.openxmlformats.org/presentationml/2006/main">
+<p:sld xmlns:a="http://schemas.openxmlformats.org/drawingml/2006/main" xmlns:p="http://schemas.openxmlformats.org/presentationml/2006/main">
   <p:cSld name="Slide 3">
     <p:bg>
       <p:bgPr>
@@ -3642,7 +3666,7 @@
     </p:bg>
     <p:spTree>
       <p:nvGrpSpPr>
-        <p:cNvPr id="1" name=""/>
+        <p:cNvPr id="55" name=""/>
         <p:cNvGrpSpPr/>
         <p:nvPr/>
       </p:nvGrpSpPr>
@@ -3656,7 +3680,7 @@
       </p:grpSpPr>
       <p:sp>
         <p:nvSpPr>
-          <p:cNvPr id="2" name="Text 0"/>
+          <p:cNvPr id="56" name="Text 0"/>
           <p:cNvSpPr/>
           <p:nvPr/>
         </p:nvSpPr>
@@ -3675,7 +3699,7 @@
           <a:bodyPr wrap="square" rtlCol="0" anchor="ctr"/>
           <a:lstStyle/>
           <a:p>
-            <a:pPr indent="0" marL="0">
+            <a:pPr marL="0" indent="0">
               <a:buNone/>
             </a:pPr>
             <a:r>
@@ -3695,7 +3719,7 @@
       </p:sp>
       <p:sp>
         <p:nvSpPr>
-          <p:cNvPr id="3" name="Text 1"/>
+          <p:cNvPr id="57" name="Text 1"/>
           <p:cNvSpPr/>
           <p:nvPr/>
         </p:nvSpPr>
@@ -3714,7 +3738,7 @@
           <a:bodyPr wrap="square" rtlCol="0" anchor="ctr"/>
           <a:lstStyle/>
           <a:p>
-            <a:pPr indent="0" marL="0">
+            <a:pPr marL="0" indent="0">
               <a:buNone/>
             </a:pPr>
             <a:r>
@@ -3734,7 +3758,7 @@
       </p:sp>
       <p:sp>
         <p:nvSpPr>
-          <p:cNvPr id="4" name="Shape 2"/>
+          <p:cNvPr id="58" name="Shape 2"/>
           <p:cNvSpPr/>
           <p:nvPr/>
         </p:nvSpPr>
@@ -3758,10 +3782,14 @@
             <a:prstDash val="solid"/>
           </a:ln>
         </p:spPr>
-      </p:sp>
-      <p:sp>
-        <p:nvSpPr>
-          <p:cNvPr id="5" name="Text 3"/>
+        <p:txBody>
+          <a:bodyPr/>
+          <a:p/>
+        </p:txBody>
+      </p:sp>
+      <p:sp>
+        <p:nvSpPr>
+          <p:cNvPr id="59" name="Text 3"/>
           <p:cNvSpPr/>
           <p:nvPr/>
         </p:nvSpPr>
@@ -3780,7 +3808,7 @@
           <a:bodyPr wrap="square" rtlCol="0" anchor="ctr"/>
           <a:lstStyle/>
           <a:p>
-            <a:pPr indent="0" marL="0">
+            <a:pPr marL="0" indent="0">
               <a:buNone/>
             </a:pPr>
             <a:r>
@@ -3800,7 +3828,7 @@
       </p:sp>
       <p:sp>
         <p:nvSpPr>
-          <p:cNvPr id="6" name="Text 4"/>
+          <p:cNvPr id="60" name="Text 4"/>
           <p:cNvSpPr/>
           <p:nvPr/>
         </p:nvSpPr>
@@ -3819,7 +3847,7 @@
           <a:bodyPr wrap="square" rtlCol="0" anchor="ctr"/>
           <a:lstStyle/>
           <a:p>
-            <a:pPr indent="0" marL="0">
+            <a:pPr marL="0" indent="0">
               <a:buNone/>
             </a:pPr>
             <a:r>
@@ -3839,7 +3867,7 @@
       </p:sp>
       <p:sp>
         <p:nvSpPr>
-          <p:cNvPr id="7" name="Shape 5"/>
+          <p:cNvPr id="61" name="Shape 5"/>
           <p:cNvSpPr/>
           <p:nvPr/>
         </p:nvSpPr>
@@ -3863,10 +3891,14 @@
             <a:prstDash val="solid"/>
           </a:ln>
         </p:spPr>
-      </p:sp>
-      <p:sp>
-        <p:nvSpPr>
-          <p:cNvPr id="8" name="Text 6"/>
+        <p:txBody>
+          <a:bodyPr/>
+          <a:p/>
+        </p:txBody>
+      </p:sp>
+      <p:sp>
+        <p:nvSpPr>
+          <p:cNvPr id="62" name="Text 6"/>
           <p:cNvSpPr/>
           <p:nvPr/>
         </p:nvSpPr>
@@ -3885,7 +3917,7 @@
           <a:bodyPr wrap="square" rtlCol="0" anchor="ctr"/>
           <a:lstStyle/>
           <a:p>
-            <a:pPr indent="0" marL="0">
+            <a:pPr marL="0" indent="0">
               <a:buNone/>
             </a:pPr>
             <a:r>
@@ -3905,7 +3937,7 @@
       </p:sp>
       <p:sp>
         <p:nvSpPr>
-          <p:cNvPr id="9" name="Text 7"/>
+          <p:cNvPr id="63" name="Text 7"/>
           <p:cNvSpPr/>
           <p:nvPr/>
         </p:nvSpPr>
@@ -3924,7 +3956,7 @@
           <a:bodyPr wrap="square" rtlCol="0" anchor="ctr"/>
           <a:lstStyle/>
           <a:p>
-            <a:pPr indent="0" marL="0">
+            <a:pPr marL="0" indent="0">
               <a:buNone/>
             </a:pPr>
             <a:r>
@@ -3944,7 +3976,7 @@
       </p:sp>
       <p:sp>
         <p:nvSpPr>
-          <p:cNvPr id="10" name="Shape 8"/>
+          <p:cNvPr id="64" name="Shape 8"/>
           <p:cNvSpPr/>
           <p:nvPr/>
         </p:nvSpPr>
@@ -3968,10 +4000,14 @@
             <a:prstDash val="solid"/>
           </a:ln>
         </p:spPr>
-      </p:sp>
-      <p:sp>
-        <p:nvSpPr>
-          <p:cNvPr id="11" name="Text 9"/>
+        <p:txBody>
+          <a:bodyPr/>
+          <a:p/>
+        </p:txBody>
+      </p:sp>
+      <p:sp>
+        <p:nvSpPr>
+          <p:cNvPr id="65" name="Text 9"/>
           <p:cNvSpPr/>
           <p:nvPr/>
         </p:nvSpPr>
@@ -3990,7 +4026,7 @@
           <a:bodyPr wrap="square" rtlCol="0" anchor="ctr"/>
           <a:lstStyle/>
           <a:p>
-            <a:pPr indent="0" marL="0">
+            <a:pPr marL="0" indent="0">
               <a:buNone/>
             </a:pPr>
             <a:r>
@@ -4010,7 +4046,7 @@
       </p:sp>
       <p:sp>
         <p:nvSpPr>
-          <p:cNvPr id="12" name="Text 10"/>
+          <p:cNvPr id="66" name="Text 10"/>
           <p:cNvSpPr/>
           <p:nvPr/>
         </p:nvSpPr>
@@ -4029,7 +4065,7 @@
           <a:bodyPr wrap="square" rtlCol="0" anchor="ctr"/>
           <a:lstStyle/>
           <a:p>
-            <a:pPr indent="0" marL="0">
+            <a:pPr marL="0" indent="0">
               <a:buNone/>
             </a:pPr>
             <a:r>
@@ -4049,7 +4085,7 @@
       </p:sp>
       <p:sp>
         <p:nvSpPr>
-          <p:cNvPr id="13" name="Shape 11"/>
+          <p:cNvPr id="67" name="Shape 11"/>
           <p:cNvSpPr/>
           <p:nvPr/>
         </p:nvSpPr>
@@ -4073,10 +4109,14 @@
             <a:prstDash val="solid"/>
           </a:ln>
         </p:spPr>
-      </p:sp>
-      <p:sp>
-        <p:nvSpPr>
-          <p:cNvPr id="14" name="Text 12"/>
+        <p:txBody>
+          <a:bodyPr/>
+          <a:p/>
+        </p:txBody>
+      </p:sp>
+      <p:sp>
+        <p:nvSpPr>
+          <p:cNvPr id="68" name="Text 12"/>
           <p:cNvSpPr/>
           <p:nvPr/>
         </p:nvSpPr>
@@ -4095,7 +4135,7 @@
           <a:bodyPr wrap="square" rtlCol="0" anchor="ctr"/>
           <a:lstStyle/>
           <a:p>
-            <a:pPr indent="0" marL="0">
+            <a:pPr marL="0" indent="0">
               <a:buNone/>
             </a:pPr>
             <a:r>
@@ -4115,7 +4155,7 @@
       </p:sp>
       <p:sp>
         <p:nvSpPr>
-          <p:cNvPr id="15" name="Text 13"/>
+          <p:cNvPr id="69" name="Text 13"/>
           <p:cNvSpPr/>
           <p:nvPr/>
         </p:nvSpPr>
@@ -4134,7 +4174,7 @@
           <a:bodyPr wrap="square" rtlCol="0" anchor="ctr"/>
           <a:lstStyle/>
           <a:p>
-            <a:pPr indent="0" marL="0">
+            <a:pPr marL="0" indent="0">
               <a:buNone/>
             </a:pPr>
             <a:r>
@@ -4154,7 +4194,7 @@
       </p:sp>
       <p:sp>
         <p:nvSpPr>
-          <p:cNvPr id="16" name="Shape 14"/>
+          <p:cNvPr id="70" name="Shape 14"/>
           <p:cNvSpPr/>
           <p:nvPr/>
         </p:nvSpPr>
@@ -4171,10 +4211,14 @@
           </a:solidFill>
           <a:ln/>
         </p:spPr>
-      </p:sp>
-      <p:sp>
-        <p:nvSpPr>
-          <p:cNvPr id="17" name="Text 15"/>
+        <p:txBody>
+          <a:bodyPr/>
+          <a:p/>
+        </p:txBody>
+      </p:sp>
+      <p:sp>
+        <p:nvSpPr>
+          <p:cNvPr id="71" name="Text 15"/>
           <p:cNvSpPr/>
           <p:nvPr/>
         </p:nvSpPr>
@@ -4193,7 +4237,7 @@
           <a:bodyPr wrap="square" rtlCol="0" anchor="ctr"/>
           <a:lstStyle/>
           <a:p>
-            <a:pPr algn="ctr" indent="0" marL="0">
+            <a:pPr marL="0" indent="0" algn="ctr">
               <a:buNone/>
             </a:pPr>
             <a:r>
@@ -4220,7 +4264,7 @@
 </file>
 
 <file path=ppt/slides/slide4.xml><?xml version="1.0" encoding="utf-8"?>
-<p:sld xmlns:a="http://schemas.openxmlformats.org/drawingml/2006/main" xmlns:r="http://schemas.openxmlformats.org/officeDocument/2006/relationships" xmlns:p="http://schemas.openxmlformats.org/presentationml/2006/main">
+<p:sld xmlns:a="http://schemas.openxmlformats.org/drawingml/2006/main" xmlns:p="http://schemas.openxmlformats.org/presentationml/2006/main">
   <p:cSld name="Slide 4">
     <p:bg>
       <p:bgPr>
@@ -4231,7 +4275,7 @@
     </p:bg>
     <p:spTree>
       <p:nvGrpSpPr>
-        <p:cNvPr id="1" name=""/>
+        <p:cNvPr id="72" name=""/>
         <p:cNvGrpSpPr/>
         <p:nvPr/>
       </p:nvGrpSpPr>
@@ -4245,7 +4289,7 @@
       </p:grpSpPr>
       <p:sp>
         <p:nvSpPr>
-          <p:cNvPr id="2" name="Text 0"/>
+          <p:cNvPr id="73" name="Text 0"/>
           <p:cNvSpPr/>
           <p:nvPr/>
         </p:nvSpPr>
@@ -4264,7 +4308,7 @@
           <a:bodyPr wrap="square" rtlCol="0" anchor="ctr"/>
           <a:lstStyle/>
           <a:p>
-            <a:pPr indent="0" marL="0">
+            <a:pPr marL="0" indent="0">
               <a:buNone/>
             </a:pPr>
             <a:r>
@@ -4284,7 +4328,7 @@
       </p:sp>
       <p:sp>
         <p:nvSpPr>
-          <p:cNvPr id="3" name="Text 1"/>
+          <p:cNvPr id="74" name="Text 1"/>
           <p:cNvSpPr/>
           <p:nvPr/>
         </p:nvSpPr>
@@ -4303,7 +4347,7 @@
           <a:bodyPr wrap="square" rtlCol="0" anchor="ctr"/>
           <a:lstStyle/>
           <a:p>
-            <a:pPr indent="0" marL="0">
+            <a:pPr marL="0" indent="0">
               <a:buNone/>
             </a:pPr>
             <a:r>
@@ -4323,7 +4367,7 @@
       </p:sp>
       <p:sp>
         <p:nvSpPr>
-          <p:cNvPr id="4" name="Shape 2"/>
+          <p:cNvPr id="75" name="Shape 2"/>
           <p:cNvSpPr/>
           <p:nvPr/>
         </p:nvSpPr>
@@ -4347,10 +4391,14 @@
             <a:prstDash val="solid"/>
           </a:ln>
         </p:spPr>
-      </p:sp>
-      <p:sp>
-        <p:nvSpPr>
-          <p:cNvPr id="5" name="Text 3"/>
+        <p:txBody>
+          <a:bodyPr/>
+          <a:p/>
+        </p:txBody>
+      </p:sp>
+      <p:sp>
+        <p:nvSpPr>
+          <p:cNvPr id="76" name="Text 3"/>
           <p:cNvSpPr/>
           <p:nvPr/>
         </p:nvSpPr>
@@ -4369,7 +4417,7 @@
           <a:bodyPr wrap="square" rtlCol="0" anchor="ctr"/>
           <a:lstStyle/>
           <a:p>
-            <a:pPr indent="0" marL="0">
+            <a:pPr marL="0" indent="0">
               <a:buNone/>
             </a:pPr>
             <a:r>
@@ -4389,7 +4437,7 @@
       </p:sp>
       <p:sp>
         <p:nvSpPr>
-          <p:cNvPr id="6" name="Text 4"/>
+          <p:cNvPr id="77" name="Text 4"/>
           <p:cNvSpPr/>
           <p:nvPr/>
         </p:nvSpPr>
@@ -4408,7 +4456,7 @@
           <a:bodyPr wrap="square" rtlCol="0" anchor="ctr"/>
           <a:lstStyle/>
           <a:p>
-            <a:pPr indent="0" marL="0">
+            <a:pPr marL="0" indent="0">
               <a:buNone/>
             </a:pPr>
             <a:r>
@@ -4428,7 +4476,7 @@
       </p:sp>
       <p:sp>
         <p:nvSpPr>
-          <p:cNvPr id="7" name="Shape 5"/>
+          <p:cNvPr id="78" name="Shape 5"/>
           <p:cNvSpPr/>
           <p:nvPr/>
         </p:nvSpPr>
@@ -4452,10 +4500,14 @@
             <a:prstDash val="solid"/>
           </a:ln>
         </p:spPr>
-      </p:sp>
-      <p:sp>
-        <p:nvSpPr>
-          <p:cNvPr id="8" name="Text 6"/>
+        <p:txBody>
+          <a:bodyPr/>
+          <a:p/>
+        </p:txBody>
+      </p:sp>
+      <p:sp>
+        <p:nvSpPr>
+          <p:cNvPr id="79" name="Text 6"/>
           <p:cNvSpPr/>
           <p:nvPr/>
         </p:nvSpPr>
@@ -4474,7 +4526,7 @@
           <a:bodyPr wrap="square" rtlCol="0" anchor="ctr"/>
           <a:lstStyle/>
           <a:p>
-            <a:pPr indent="0" marL="0">
+            <a:pPr marL="0" indent="0">
               <a:buNone/>
             </a:pPr>
             <a:r>
@@ -4494,7 +4546,7 @@
       </p:sp>
       <p:sp>
         <p:nvSpPr>
-          <p:cNvPr id="9" name="Text 7"/>
+          <p:cNvPr id="80" name="Text 7"/>
           <p:cNvSpPr/>
           <p:nvPr/>
         </p:nvSpPr>
@@ -4513,7 +4565,7 @@
           <a:bodyPr wrap="square" rtlCol="0" anchor="ctr"/>
           <a:lstStyle/>
           <a:p>
-            <a:pPr indent="0" marL="0">
+            <a:pPr marL="0" indent="0">
               <a:buNone/>
             </a:pPr>
             <a:r>
@@ -4533,7 +4585,7 @@
       </p:sp>
       <p:sp>
         <p:nvSpPr>
-          <p:cNvPr id="10" name="Shape 8"/>
+          <p:cNvPr id="81" name="Shape 8"/>
           <p:cNvSpPr/>
           <p:nvPr/>
         </p:nvSpPr>
@@ -4557,10 +4609,14 @@
             <a:prstDash val="solid"/>
           </a:ln>
         </p:spPr>
-      </p:sp>
-      <p:sp>
-        <p:nvSpPr>
-          <p:cNvPr id="11" name="Text 9"/>
+        <p:txBody>
+          <a:bodyPr/>
+          <a:p/>
+        </p:txBody>
+      </p:sp>
+      <p:sp>
+        <p:nvSpPr>
+          <p:cNvPr id="82" name="Text 9"/>
           <p:cNvSpPr/>
           <p:nvPr/>
         </p:nvSpPr>
@@ -4579,7 +4635,7 @@
           <a:bodyPr wrap="square" rtlCol="0" anchor="ctr"/>
           <a:lstStyle/>
           <a:p>
-            <a:pPr indent="0" marL="0">
+            <a:pPr marL="0" indent="0">
               <a:buNone/>
             </a:pPr>
             <a:r>
@@ -4599,7 +4655,7 @@
       </p:sp>
       <p:sp>
         <p:nvSpPr>
-          <p:cNvPr id="12" name="Text 10"/>
+          <p:cNvPr id="83" name="Text 10"/>
           <p:cNvSpPr/>
           <p:nvPr/>
         </p:nvSpPr>
@@ -4618,7 +4674,7 @@
           <a:bodyPr wrap="square" rtlCol="0" anchor="ctr"/>
           <a:lstStyle/>
           <a:p>
-            <a:pPr indent="0" marL="0">
+            <a:pPr marL="0" indent="0">
               <a:buNone/>
             </a:pPr>
             <a:r>
@@ -4638,7 +4694,7 @@
       </p:sp>
       <p:sp>
         <p:nvSpPr>
-          <p:cNvPr id="13" name="Shape 11"/>
+          <p:cNvPr id="84" name="Shape 11"/>
           <p:cNvSpPr/>
           <p:nvPr/>
         </p:nvSpPr>
@@ -4655,10 +4711,14 @@
           </a:solidFill>
           <a:ln/>
         </p:spPr>
-      </p:sp>
-      <p:sp>
-        <p:nvSpPr>
-          <p:cNvPr id="14" name="Text 12"/>
+        <p:txBody>
+          <a:bodyPr/>
+          <a:p/>
+        </p:txBody>
+      </p:sp>
+      <p:sp>
+        <p:nvSpPr>
+          <p:cNvPr id="85" name="Text 12"/>
           <p:cNvSpPr/>
           <p:nvPr/>
         </p:nvSpPr>
@@ -4677,7 +4737,7 @@
           <a:bodyPr wrap="square" rtlCol="0" anchor="ctr"/>
           <a:lstStyle/>
           <a:p>
-            <a:pPr algn="ctr" indent="0" marL="0">
+            <a:pPr marL="0" indent="0" algn="ctr">
               <a:buNone/>
             </a:pPr>
             <a:r>
@@ -4715,7 +4775,7 @@
     </p:bg>
     <p:spTree>
       <p:nvGrpSpPr>
-        <p:cNvPr id="1" name=""/>
+        <p:cNvPr id="86" name=""/>
         <p:cNvGrpSpPr/>
         <p:nvPr/>
       </p:nvGrpSpPr>
@@ -4729,7 +4789,7 @@
       </p:grpSpPr>
       <p:sp>
         <p:nvSpPr>
-          <p:cNvPr id="2" name="Text 0"/>
+          <p:cNvPr id="87" name="Text 0"/>
           <p:cNvSpPr/>
           <p:nvPr/>
         </p:nvSpPr>
@@ -4748,7 +4808,7 @@
           <a:bodyPr wrap="square" rtlCol="0" anchor="ctr"/>
           <a:lstStyle/>
           <a:p>
-            <a:pPr indent="0" marL="0">
+            <a:pPr marL="0" indent="0">
               <a:buNone/>
             </a:pPr>
             <a:r>
@@ -4768,7 +4828,7 @@
       </p:sp>
       <p:sp>
         <p:nvSpPr>
-          <p:cNvPr id="3" name="Text 1"/>
+          <p:cNvPr id="88" name="Text 1"/>
           <p:cNvSpPr/>
           <p:nvPr/>
         </p:nvSpPr>
@@ -4787,7 +4847,7 @@
           <a:bodyPr wrap="square" rtlCol="0" anchor="ctr"/>
           <a:lstStyle/>
           <a:p>
-            <a:pPr indent="0" marL="0">
+            <a:pPr marL="0" indent="0">
               <a:buNone/>
             </a:pPr>
             <a:r>
@@ -4807,14 +4867,14 @@
       </p:sp>
       <p:pic>
         <p:nvPicPr>
-          <p:cNvPr id="4" name="Image 0" descr="/Users/nick/Hack/kuairand-recommender-agent/video_assets/06_architecture.png">    </p:cNvPr>
+          <p:cNvPr id="89" name="Image 0" descr="/Users/nick/Hack/kuairand-recommender-agent/video_assets/06_architecture.png"/>
           <p:cNvPicPr>
             <a:picLocks noChangeAspect="1"/>
           </p:cNvPicPr>
           <p:nvPr/>
         </p:nvPicPr>
         <p:blipFill>
-          <a:blip r:embed="rId1"/>
+          <a:blip r:embed="rId2"/>
           <a:stretch>
             <a:fillRect/>
           </a:stretch>
@@ -4831,7 +4891,7 @@
       </p:pic>
       <p:sp>
         <p:nvSpPr>
-          <p:cNvPr id="5" name="Text 2"/>
+          <p:cNvPr id="90" name="Text 2"/>
           <p:cNvSpPr/>
           <p:nvPr/>
         </p:nvSpPr>
@@ -4850,7 +4910,7 @@
           <a:bodyPr wrap="square" rtlCol="0" anchor="ctr"/>
           <a:lstStyle/>
           <a:p>
-            <a:pPr algn="ctr" indent="0" marL="0">
+            <a:pPr marL="0" indent="0" algn="ctr">
               <a:buNone/>
             </a:pPr>
             <a:r>
@@ -4870,7 +4930,7 @@
       </p:sp>
       <p:sp>
         <p:nvSpPr>
-          <p:cNvPr id="6" name="Shape 3"/>
+          <p:cNvPr id="91" name="Shape 3"/>
           <p:cNvSpPr/>
           <p:nvPr/>
         </p:nvSpPr>
@@ -4887,10 +4947,14 @@
           </a:solidFill>
           <a:ln/>
         </p:spPr>
-      </p:sp>
-      <p:sp>
-        <p:nvSpPr>
-          <p:cNvPr id="7" name="Text 4"/>
+        <p:txBody>
+          <a:bodyPr/>
+          <a:p/>
+        </p:txBody>
+      </p:sp>
+      <p:sp>
+        <p:nvSpPr>
+          <p:cNvPr id="92" name="Text 4"/>
           <p:cNvSpPr/>
           <p:nvPr/>
         </p:nvSpPr>
@@ -4909,7 +4973,7 @@
           <a:bodyPr wrap="square" rtlCol="0" anchor="ctr"/>
           <a:lstStyle/>
           <a:p>
-            <a:pPr algn="ctr" indent="0" marL="0">
+            <a:pPr marL="0" indent="0" algn="ctr">
               <a:buNone/>
             </a:pPr>
             <a:r>
@@ -4947,7 +5011,7 @@
     </p:bg>
     <p:spTree>
       <p:nvGrpSpPr>
-        <p:cNvPr id="1" name=""/>
+        <p:cNvPr id="93" name=""/>
         <p:cNvGrpSpPr/>
         <p:nvPr/>
       </p:nvGrpSpPr>
@@ -4961,7 +5025,7 @@
       </p:grpSpPr>
       <p:sp>
         <p:nvSpPr>
-          <p:cNvPr id="2" name="Text 0"/>
+          <p:cNvPr id="94" name="Text 0"/>
           <p:cNvSpPr/>
           <p:nvPr/>
         </p:nvSpPr>
@@ -4980,7 +5044,7 @@
           <a:bodyPr wrap="square" rtlCol="0" anchor="ctr"/>
           <a:lstStyle/>
           <a:p>
-            <a:pPr indent="0" marL="0">
+            <a:pPr marL="0" indent="0">
               <a:buNone/>
             </a:pPr>
             <a:r>
@@ -5000,7 +5064,7 @@
       </p:sp>
       <p:sp>
         <p:nvSpPr>
-          <p:cNvPr id="3" name="Text 1"/>
+          <p:cNvPr id="95" name="Text 1"/>
           <p:cNvSpPr/>
           <p:nvPr/>
         </p:nvSpPr>
@@ -5019,7 +5083,7 @@
           <a:bodyPr wrap="square" rtlCol="0" anchor="ctr"/>
           <a:lstStyle/>
           <a:p>
-            <a:pPr indent="0" marL="0">
+            <a:pPr marL="0" indent="0">
               <a:buNone/>
             </a:pPr>
             <a:r>
@@ -5039,14 +5103,14 @@
       </p:sp>
       <p:pic>
         <p:nvPicPr>
-          <p:cNvPr id="4" name="Image 0" descr="/Users/nick/Hack/kuairand-recommender-agent/video_assets/02_score_comparison.png">    </p:cNvPr>
+          <p:cNvPr id="96" name="Image 0" descr="/Users/nick/Hack/kuairand-recommender-agent/video_assets/02_score_comparison.png"/>
           <p:cNvPicPr>
             <a:picLocks noChangeAspect="1"/>
           </p:cNvPicPr>
           <p:nvPr/>
         </p:nvPicPr>
         <p:blipFill>
-          <a:blip r:embed="rId1"/>
+          <a:blip r:embed="rId2"/>
           <a:stretch>
             <a:fillRect/>
           </a:stretch>
@@ -5063,7 +5127,7 @@
       </p:pic>
       <p:sp>
         <p:nvSpPr>
-          <p:cNvPr id="5" name="Shape 2"/>
+          <p:cNvPr id="97" name="Shape 2"/>
           <p:cNvSpPr/>
           <p:nvPr/>
         </p:nvSpPr>
@@ -5080,10 +5144,14 @@
           </a:solidFill>
           <a:ln/>
         </p:spPr>
-      </p:sp>
-      <p:sp>
-        <p:nvSpPr>
-          <p:cNvPr id="6" name="Text 3"/>
+        <p:txBody>
+          <a:bodyPr/>
+          <a:p/>
+        </p:txBody>
+      </p:sp>
+      <p:sp>
+        <p:nvSpPr>
+          <p:cNvPr id="98" name="Text 3"/>
           <p:cNvSpPr/>
           <p:nvPr/>
         </p:nvSpPr>
@@ -5102,7 +5170,7 @@
           <a:bodyPr wrap="square" rtlCol="0" anchor="ctr"/>
           <a:lstStyle/>
           <a:p>
-            <a:pPr algn="ctr" indent="0" marL="0">
+            <a:pPr marL="0" indent="0" algn="ctr">
               <a:buNone/>
             </a:pPr>
             <a:r>
@@ -5140,7 +5208,7 @@
     </p:bg>
     <p:spTree>
       <p:nvGrpSpPr>
-        <p:cNvPr id="1" name=""/>
+        <p:cNvPr id="99" name=""/>
         <p:cNvGrpSpPr/>
         <p:nvPr/>
       </p:nvGrpSpPr>
@@ -5154,7 +5222,7 @@
       </p:grpSpPr>
       <p:sp>
         <p:nvSpPr>
-          <p:cNvPr id="2" name="Text 0"/>
+          <p:cNvPr id="100" name="Text 0"/>
           <p:cNvSpPr/>
           <p:nvPr/>
         </p:nvSpPr>
@@ -5173,7 +5241,7 @@
           <a:bodyPr wrap="square" rtlCol="0" anchor="ctr"/>
           <a:lstStyle/>
           <a:p>
-            <a:pPr indent="0" marL="0">
+            <a:pPr marL="0" indent="0">
               <a:buNone/>
             </a:pPr>
             <a:r>
@@ -5193,7 +5261,7 @@
       </p:sp>
       <p:sp>
         <p:nvSpPr>
-          <p:cNvPr id="3" name="Text 1"/>
+          <p:cNvPr id="101" name="Text 1"/>
           <p:cNvSpPr/>
           <p:nvPr/>
         </p:nvSpPr>
@@ -5212,7 +5280,7 @@
           <a:bodyPr wrap="square" rtlCol="0" anchor="ctr"/>
           <a:lstStyle/>
           <a:p>
-            <a:pPr indent="0" marL="0">
+            <a:pPr marL="0" indent="0">
               <a:buNone/>
             </a:pPr>
             <a:r>
@@ -5232,14 +5300,14 @@
       </p:sp>
       <p:pic>
         <p:nvPicPr>
-          <p:cNvPr id="4" name="Image 0" descr="/Users/nick/Hack/kuairand-recommender-agent/video_assets/03_iteration_trajectory.png">    </p:cNvPr>
+          <p:cNvPr id="102" name="Image 0" descr="/Users/nick/Hack/kuairand-recommender-agent/video_assets/03_iteration_trajectory.png"/>
           <p:cNvPicPr>
             <a:picLocks noChangeAspect="1"/>
           </p:cNvPicPr>
           <p:nvPr/>
         </p:nvPicPr>
         <p:blipFill>
-          <a:blip r:embed="rId1"/>
+          <a:blip r:embed="rId2"/>
           <a:stretch>
             <a:fillRect/>
           </a:stretch>
@@ -5256,7 +5324,7 @@
       </p:pic>
       <p:sp>
         <p:nvSpPr>
-          <p:cNvPr id="5" name="Shape 2"/>
+          <p:cNvPr id="103" name="Shape 2"/>
           <p:cNvSpPr/>
           <p:nvPr/>
         </p:nvSpPr>
@@ -5273,10 +5341,14 @@
           </a:solidFill>
           <a:ln/>
         </p:spPr>
-      </p:sp>
-      <p:sp>
-        <p:nvSpPr>
-          <p:cNvPr id="6" name="Text 3"/>
+        <p:txBody>
+          <a:bodyPr/>
+          <a:p/>
+        </p:txBody>
+      </p:sp>
+      <p:sp>
+        <p:nvSpPr>
+          <p:cNvPr id="104" name="Text 3"/>
           <p:cNvSpPr/>
           <p:nvPr/>
         </p:nvSpPr>
@@ -5295,7 +5367,7 @@
           <a:bodyPr wrap="square" rtlCol="0" anchor="ctr"/>
           <a:lstStyle/>
           <a:p>
-            <a:pPr algn="ctr" indent="0" marL="0">
+            <a:pPr marL="0" indent="0" algn="ctr">
               <a:buNone/>
             </a:pPr>
             <a:r>
@@ -5333,7 +5405,7 @@
     </p:bg>
     <p:spTree>
       <p:nvGrpSpPr>
-        <p:cNvPr id="1" name=""/>
+        <p:cNvPr id="105" name=""/>
         <p:cNvGrpSpPr/>
         <p:nvPr/>
       </p:nvGrpSpPr>
@@ -5347,7 +5419,7 @@
       </p:grpSpPr>
       <p:sp>
         <p:nvSpPr>
-          <p:cNvPr id="2" name="Text 0"/>
+          <p:cNvPr id="106" name="Text 0"/>
           <p:cNvSpPr/>
           <p:nvPr/>
         </p:nvSpPr>
@@ -5366,7 +5438,7 @@
           <a:bodyPr wrap="square" rtlCol="0" anchor="ctr"/>
           <a:lstStyle/>
           <a:p>
-            <a:pPr indent="0" marL="0">
+            <a:pPr marL="0" indent="0">
               <a:buNone/>
             </a:pPr>
             <a:r>
@@ -5386,7 +5458,7 @@
       </p:sp>
       <p:sp>
         <p:nvSpPr>
-          <p:cNvPr id="3" name="Text 1"/>
+          <p:cNvPr id="107" name="Text 1"/>
           <p:cNvSpPr/>
           <p:nvPr/>
         </p:nvSpPr>
@@ -5405,7 +5477,7 @@
           <a:bodyPr wrap="square" rtlCol="0" anchor="ctr"/>
           <a:lstStyle/>
           <a:p>
-            <a:pPr indent="0" marL="0">
+            <a:pPr marL="0" indent="0">
               <a:buNone/>
             </a:pPr>
             <a:r>
@@ -5425,14 +5497,14 @@
       </p:sp>
       <p:pic>
         <p:nvPicPr>
-          <p:cNvPr id="4" name="Image 0" descr="/Users/nick/Hack/kuairand-recommender-agent/video_assets/04_leakage_guard.png">    </p:cNvPr>
+          <p:cNvPr id="108" name="Image 0" descr="/Users/nick/Hack/kuairand-recommender-agent/video_assets/04_leakage_guard.png"/>
           <p:cNvPicPr>
             <a:picLocks noChangeAspect="1"/>
           </p:cNvPicPr>
           <p:nvPr/>
         </p:nvPicPr>
         <p:blipFill>
-          <a:blip r:embed="rId1"/>
+          <a:blip r:embed="rId2"/>
           <a:stretch>
             <a:fillRect/>
           </a:stretch>
@@ -5449,7 +5521,7 @@
       </p:pic>
       <p:sp>
         <p:nvSpPr>
-          <p:cNvPr id="5" name="Shape 2"/>
+          <p:cNvPr id="109" name="Shape 2"/>
           <p:cNvSpPr/>
           <p:nvPr/>
         </p:nvSpPr>
@@ -5466,10 +5538,14 @@
           </a:solidFill>
           <a:ln/>
         </p:spPr>
-      </p:sp>
-      <p:sp>
-        <p:nvSpPr>
-          <p:cNvPr id="6" name="Text 3"/>
+        <p:txBody>
+          <a:bodyPr/>
+          <a:p/>
+        </p:txBody>
+      </p:sp>
+      <p:sp>
+        <p:nvSpPr>
+          <p:cNvPr id="110" name="Text 3"/>
           <p:cNvSpPr/>
           <p:nvPr/>
         </p:nvSpPr>
@@ -5488,7 +5564,7 @@
           <a:bodyPr wrap="square" rtlCol="0" anchor="ctr"/>
           <a:lstStyle/>
           <a:p>
-            <a:pPr algn="ctr" indent="0" marL="0">
+            <a:pPr marL="0" indent="0" algn="ctr">
               <a:buNone/>
             </a:pPr>
             <a:r>
@@ -5526,7 +5602,7 @@
     </p:bg>
     <p:spTree>
       <p:nvGrpSpPr>
-        <p:cNvPr id="1" name=""/>
+        <p:cNvPr id="111" name=""/>
         <p:cNvGrpSpPr/>
         <p:nvPr/>
       </p:nvGrpSpPr>
@@ -5540,7 +5616,7 @@
       </p:grpSpPr>
       <p:sp>
         <p:nvSpPr>
-          <p:cNvPr id="2" name="Text 0"/>
+          <p:cNvPr id="112" name="Text 0"/>
           <p:cNvSpPr/>
           <p:nvPr/>
         </p:nvSpPr>
@@ -5559,7 +5635,7 @@
           <a:bodyPr wrap="square" rtlCol="0" anchor="ctr"/>
           <a:lstStyle/>
           <a:p>
-            <a:pPr indent="0" marL="0">
+            <a:pPr marL="0" indent="0">
               <a:buNone/>
             </a:pPr>
             <a:r>
@@ -5579,7 +5655,7 @@
       </p:sp>
       <p:sp>
         <p:nvSpPr>
-          <p:cNvPr id="3" name="Text 1"/>
+          <p:cNvPr id="113" name="Text 1"/>
           <p:cNvSpPr/>
           <p:nvPr/>
         </p:nvSpPr>
@@ -5598,7 +5674,7 @@
           <a:bodyPr wrap="square" rtlCol="0" anchor="ctr"/>
           <a:lstStyle/>
           <a:p>
-            <a:pPr indent="0" marL="0">
+            <a:pPr marL="0" indent="0">
               <a:buNone/>
             </a:pPr>
             <a:r>
@@ -5618,14 +5694,14 @@
       </p:sp>
       <p:pic>
         <p:nvPicPr>
-          <p:cNvPr id="4" name="Image 0" descr="/Users/nick/Hack/kuairand-recommender-agent/video_assets/05_time_decay.png">    </p:cNvPr>
+          <p:cNvPr id="114" name="Image 0" descr="/Users/nick/Hack/kuairand-recommender-agent/video_assets/05_time_decay.png"/>
           <p:cNvPicPr>
             <a:picLocks noChangeAspect="1"/>
           </p:cNvPicPr>
           <p:nvPr/>
         </p:nvPicPr>
         <p:blipFill>
-          <a:blip r:embed="rId1"/>
+          <a:blip r:embed="rId2"/>
           <a:stretch>
             <a:fillRect/>
           </a:stretch>
@@ -5642,7 +5718,7 @@
       </p:pic>
       <p:sp>
         <p:nvSpPr>
-          <p:cNvPr id="5" name="Shape 2"/>
+          <p:cNvPr id="115" name="Shape 2"/>
           <p:cNvSpPr/>
           <p:nvPr/>
         </p:nvSpPr>
@@ -5659,10 +5735,14 @@
           </a:solidFill>
           <a:ln/>
         </p:spPr>
-      </p:sp>
-      <p:sp>
-        <p:nvSpPr>
-          <p:cNvPr id="6" name="Text 3"/>
+        <p:txBody>
+          <a:bodyPr/>
+          <a:p/>
+        </p:txBody>
+      </p:sp>
+      <p:sp>
+        <p:nvSpPr>
+          <p:cNvPr id="116" name="Text 3"/>
           <p:cNvSpPr/>
           <p:nvPr/>
         </p:nvSpPr>
@@ -5681,7 +5761,7 @@
           <a:bodyPr wrap="square" rtlCol="0" anchor="ctr"/>
           <a:lstStyle/>
           <a:p>
-            <a:pPr algn="ctr" indent="0" marL="0">
+            <a:pPr marL="0" indent="0" algn="ctr">
               <a:buNone/>
             </a:pPr>
             <a:r>
@@ -5992,11 +6072,299 @@
       </a:bgFillStyleLst>
     </a:fmtScheme>
   </a:themeElements>
+</a:theme>
+</file>
+
+<file path=ppt/theme/theme2.xml><?xml version="1.0" encoding="utf-8"?>
+<a:theme xmlns:thm15="http://schemas.microsoft.com/office/thememl/2012/main" xmlns:a="http://schemas.openxmlformats.org/drawingml/2006/main" xmlns:mc="http://schemas.openxmlformats.org/markup-compatibility/2006" name="Office 主题​​" mc:Ignorable="thm15">
+  <a:themeElements>
+    <a:clrScheme name="Office">
+      <a:dk1>
+        <a:sysClr val="windowText" lastClr="000000"/>
+      </a:dk1>
+      <a:lt1>
+        <a:sysClr val="window" lastClr="FFFFFF"/>
+      </a:lt1>
+      <a:dk2>
+        <a:srgbClr val="44546A"/>
+      </a:dk2>
+      <a:lt2>
+        <a:srgbClr val="E7E6E6"/>
+      </a:lt2>
+      <a:accent1>
+        <a:srgbClr val="4472C4"/>
+      </a:accent1>
+      <a:accent2>
+        <a:srgbClr val="ED7D31"/>
+      </a:accent2>
+      <a:accent3>
+        <a:srgbClr val="A5A5A5"/>
+      </a:accent3>
+      <a:accent4>
+        <a:srgbClr val="FFC000"/>
+      </a:accent4>
+      <a:accent5>
+        <a:srgbClr val="5B9BD5"/>
+      </a:accent5>
+      <a:accent6>
+        <a:srgbClr val="70AD47"/>
+      </a:accent6>
+      <a:hlink>
+        <a:srgbClr val="0563C1"/>
+      </a:hlink>
+      <a:folHlink>
+        <a:srgbClr val="954F72"/>
+      </a:folHlink>
+    </a:clrScheme>
+    <a:fontScheme name="Office">
+      <a:majorFont>
+        <a:latin typeface="等线 Light" panose="020F0302020204030204"/>
+        <a:ea typeface=""/>
+        <a:cs typeface=""/>
+        <a:font script="Jpan" typeface="游ゴシック Light"/>
+        <a:font script="Hang" typeface="맑은 고딕"/>
+        <a:font script="Hans" typeface="等线 Light"/>
+        <a:font script="Hant" typeface="新細明體"/>
+        <a:font script="Arab" typeface="Times New Roman"/>
+        <a:font script="Hebr" typeface="Times New Roman"/>
+        <a:font script="Thai" typeface="Angsana New"/>
+        <a:font script="Ethi" typeface="Nyala"/>
+        <a:font script="Beng" typeface="Vrinda"/>
+        <a:font script="Gujr" typeface="Shruti"/>
+        <a:font script="Khmr" typeface="MoolBoran"/>
+        <a:font script="Knda" typeface="Tunga"/>
+        <a:font script="Guru" typeface="Raavi"/>
+        <a:font script="Cans" typeface="Euphemia"/>
+        <a:font script="Cher" typeface="Plantagenet Cherokee"/>
+        <a:font script="Yiii" typeface="Microsoft Yi Baiti"/>
+        <a:font script="Tibt" typeface="Microsoft Himalaya"/>
+        <a:font script="Thaa" typeface="MV Boli"/>
+        <a:font script="Deva" typeface="Mangal"/>
+        <a:font script="Telu" typeface="Gautami"/>
+        <a:font script="Taml" typeface="Latha"/>
+        <a:font script="Syrc" typeface="Estrangelo Edessa"/>
+        <a:font script="Orya" typeface="Kalinga"/>
+        <a:font script="Mlym" typeface="Kartika"/>
+        <a:font script="Laoo" typeface="DokChampa"/>
+        <a:font script="Sinh" typeface="Iskoola Pota"/>
+        <a:font script="Mong" typeface="Mongolian Baiti"/>
+        <a:font script="Viet" typeface="Times New Roman"/>
+        <a:font script="Uigh" typeface="Microsoft Uighur"/>
+        <a:font script="Geor" typeface="Sylfaen"/>
+        <a:font script="Armn" typeface="Arial"/>
+        <a:font script="Bugi" typeface="Leelawadee UI"/>
+        <a:font script="Bopo" typeface="Microsoft JhengHei"/>
+        <a:font script="Java" typeface="Javanese Text"/>
+        <a:font script="Lisu" typeface="Segoe UI"/>
+        <a:font script="Mymr" typeface="Myanmar Text"/>
+        <a:font script="Nkoo" typeface="Ebrima"/>
+        <a:font script="Olck" typeface="Nirmala UI"/>
+        <a:font script="Osma" typeface="Ebrima"/>
+        <a:font script="Phag" typeface="Phagspa"/>
+        <a:font script="Syrn" typeface="Estrangelo Edessa"/>
+        <a:font script="Syrj" typeface="Estrangelo Edessa"/>
+        <a:font script="Syre" typeface="Estrangelo Edessa"/>
+        <a:font script="Sora" typeface="Nirmala UI"/>
+        <a:font script="Tale" typeface="Microsoft Tai Le"/>
+        <a:font script="Talu" typeface="Microsoft New Tai Lue"/>
+        <a:font script="Tfng" typeface="Ebrima"/>
+      </a:majorFont>
+      <a:minorFont>
+        <a:latin typeface="等线" panose="020F0502020204030204"/>
+        <a:ea typeface=""/>
+        <a:cs typeface=""/>
+        <a:font script="Jpan" typeface="游明朝"/>
+        <a:font script="Hang" typeface="맑은 고딕"/>
+        <a:font script="Hans" typeface="等线"/>
+        <a:font script="Hant" typeface="新細明體"/>
+        <a:font script="Arab" typeface="Arial"/>
+        <a:font script="Hebr" typeface="Arial"/>
+        <a:font script="Thai" typeface="Cordia New"/>
+        <a:font script="Ethi" typeface="Nyala"/>
+        <a:font script="Beng" typeface="Vrinda"/>
+        <a:font script="Gujr" typeface="Shruti"/>
+        <a:font script="Khmr" typeface="DaunPenh"/>
+        <a:font script="Knda" typeface="Tunga"/>
+        <a:font script="Guru" typeface="Raavi"/>
+        <a:font script="Cans" typeface="Euphemia"/>
+        <a:font script="Cher" typeface="Plantagenet Cherokee"/>
+        <a:font script="Yiii" typeface="Microsoft Yi Baiti"/>
+        <a:font script="Tibt" typeface="Microsoft Himalaya"/>
+        <a:font script="Thaa" typeface="MV Boli"/>
+        <a:font script="Deva" typeface="Mangal"/>
+        <a:font script="Telu" typeface="Gautami"/>
+        <a:font script="Taml" typeface="Latha"/>
+        <a:font script="Syrc" typeface="Estrangelo Edessa"/>
+        <a:font script="Orya" typeface="Kalinga"/>
+        <a:font script="Mlym" typeface="Kartika"/>
+        <a:font script="Laoo" typeface="DokChampa"/>
+        <a:font script="Sinh" typeface="Iskoola Pota"/>
+        <a:font script="Mong" typeface="Mongolian Baiti"/>
+        <a:font script="Viet" typeface="Arial"/>
+        <a:font script="Uigh" typeface="Microsoft Uighur"/>
+        <a:font script="Geor" typeface="Sylfaen"/>
+        <a:font script="Armn" typeface="Arial"/>
+        <a:font script="Bugi" typeface="Leelawadee UI"/>
+        <a:font script="Bopo" typeface="Microsoft JhengHei"/>
+        <a:font script="Java" typeface="Javanese Text"/>
+        <a:font script="Lisu" typeface="Segoe UI"/>
+        <a:font script="Mymr" typeface="Myanmar Text"/>
+        <a:font script="Nkoo" typeface="Ebrima"/>
+        <a:font script="Olck" typeface="Nirmala UI"/>
+        <a:font script="Osma" typeface="Ebrima"/>
+        <a:font script="Phag" typeface="Phagspa"/>
+        <a:font script="Syrn" typeface="Estrangelo Edessa"/>
+        <a:font script="Syrj" typeface="Estrangelo Edessa"/>
+        <a:font script="Syre" typeface="Estrangelo Edessa"/>
+        <a:font script="Sora" typeface="Nirmala UI"/>
+        <a:font script="Tale" typeface="Microsoft Tai Le"/>
+        <a:font script="Talu" typeface="Microsoft New Tai Lue"/>
+        <a:font script="Tfng" typeface="Ebrima"/>
+      </a:minorFont>
+    </a:fontScheme>
+    <a:fmtScheme name="Office">
+      <a:fillStyleLst>
+        <a:solidFill>
+          <a:schemeClr val="phClr"/>
+        </a:solidFill>
+        <a:gradFill rotWithShape="1">
+          <a:gsLst>
+            <a:gs pos="0">
+              <a:schemeClr val="phClr">
+                <a:lumMod val="110000"/>
+                <a:satMod val="105000"/>
+                <a:tint val="67000"/>
+              </a:schemeClr>
+            </a:gs>
+            <a:gs pos="50000">
+              <a:schemeClr val="phClr">
+                <a:lumMod val="105000"/>
+                <a:satMod val="103000"/>
+                <a:tint val="73000"/>
+              </a:schemeClr>
+            </a:gs>
+            <a:gs pos="100000">
+              <a:schemeClr val="phClr">
+                <a:lumMod val="105000"/>
+                <a:satMod val="109000"/>
+                <a:tint val="81000"/>
+              </a:schemeClr>
+            </a:gs>
+          </a:gsLst>
+          <a:lin ang="5400000" scaled="0"/>
+        </a:gradFill>
+        <a:gradFill rotWithShape="1">
+          <a:gsLst>
+            <a:gs pos="0">
+              <a:schemeClr val="phClr">
+                <a:satMod val="103000"/>
+                <a:lumMod val="102000"/>
+                <a:tint val="94000"/>
+              </a:schemeClr>
+            </a:gs>
+            <a:gs pos="50000">
+              <a:schemeClr val="phClr">
+                <a:satMod val="110000"/>
+                <a:lumMod val="100000"/>
+                <a:shade val="100000"/>
+              </a:schemeClr>
+            </a:gs>
+            <a:gs pos="100000">
+              <a:schemeClr val="phClr">
+                <a:lumMod val="99000"/>
+                <a:satMod val="120000"/>
+                <a:shade val="78000"/>
+              </a:schemeClr>
+            </a:gs>
+          </a:gsLst>
+          <a:lin ang="5400000" scaled="0"/>
+        </a:gradFill>
+      </a:fillStyleLst>
+      <a:lnStyleLst>
+        <a:ln w="6350" cap="flat" cmpd="sng" algn="ctr">
+          <a:solidFill>
+            <a:schemeClr val="phClr"/>
+          </a:solidFill>
+          <a:prstDash val="solid"/>
+          <a:miter lim="800000"/>
+        </a:ln>
+        <a:ln w="12700" cap="flat" cmpd="sng" algn="ctr">
+          <a:solidFill>
+            <a:schemeClr val="phClr"/>
+          </a:solidFill>
+          <a:prstDash val="solid"/>
+          <a:miter lim="800000"/>
+        </a:ln>
+        <a:ln w="19050" cap="flat" cmpd="sng" algn="ctr">
+          <a:solidFill>
+            <a:schemeClr val="phClr"/>
+          </a:solidFill>
+          <a:prstDash val="solid"/>
+          <a:miter lim="800000"/>
+        </a:ln>
+      </a:lnStyleLst>
+      <a:effectStyleLst>
+        <a:effectStyle>
+          <a:effectLst/>
+        </a:effectStyle>
+        <a:effectStyle>
+          <a:effectLst/>
+        </a:effectStyle>
+        <a:effectStyle>
+          <a:effectLst>
+            <a:outerShdw blurRad="57150" dist="19050" dir="5400000" algn="ctr" rotWithShape="0">
+              <a:srgbClr val="000000">
+                <a:alpha val="63000"/>
+              </a:srgbClr>
+            </a:outerShdw>
+          </a:effectLst>
+        </a:effectStyle>
+      </a:effectStyleLst>
+      <a:bgFillStyleLst>
+        <a:solidFill>
+          <a:schemeClr val="phClr"/>
+        </a:solidFill>
+        <a:solidFill>
+          <a:schemeClr val="phClr">
+            <a:tint val="95000"/>
+            <a:satMod val="170000"/>
+          </a:schemeClr>
+        </a:solidFill>
+        <a:gradFill rotWithShape="1">
+          <a:gsLst>
+            <a:gs pos="0">
+              <a:schemeClr val="phClr">
+                <a:tint val="93000"/>
+                <a:satMod val="150000"/>
+                <a:shade val="98000"/>
+                <a:lumMod val="102000"/>
+              </a:schemeClr>
+            </a:gs>
+            <a:gs pos="50000">
+              <a:schemeClr val="phClr">
+                <a:tint val="98000"/>
+                <a:satMod val="130000"/>
+                <a:shade val="90000"/>
+                <a:lumMod val="103000"/>
+              </a:schemeClr>
+            </a:gs>
+            <a:gs pos="100000">
+              <a:schemeClr val="phClr">
+                <a:shade val="63000"/>
+                <a:satMod val="120000"/>
+              </a:schemeClr>
+            </a:gs>
+          </a:gsLst>
+          <a:lin ang="5400000" scaled="0"/>
+        </a:gradFill>
+      </a:bgFillStyleLst>
+    </a:fmtScheme>
+  </a:themeElements>
   <a:objectDefaults/>
   <a:extraClrSchemeLst/>
   <a:extLst>
     <a:ext uri="{05A4C25C-085E-4340-85A3-A5531E510DB2}">
-      <thm15:themeFamily xmlns:thm15="http://schemas.microsoft.com/office/thememl/2012/main" name="Office Theme" id="{62F939B6-93AF-4DB8-9C6B-D6C7DFDC589F}" vid="{4A3C46E8-61CC-4603-A589-7422A47A8E4A}"/>
+      <thm15:themeFamily name="Office Theme" id="{62F939B6-93AF-4DB8-9C6B-D6C7DFDC589F}" vid="{4A3C46E8-61CC-4603-A589-7422A47A8E4A}"/>
     </a:ext>
   </a:extLst>
 </a:theme>

</xml_diff>